<commit_message>
Rebuild poster as three parts (Part I ~25%, Part II ~40%, Part III ~35%)
Part I trimmed (5->3 bullets in two text columns, 4->2 evidence figures
restored to natural aspect ratio) and compressed to a quarter of the
combined vertical space. Part II rescaled to ~40%. Part III (SIGN
Generalization) built from scratch in the same visual language: a
learning-curve chart and a new k-ablation chart (both M1 vs. M6, Task A
+ Task B), plus condensed Setup/Key-Results/Conclusion columns covering
domain shift, domain adaptation, the model-capacity contrast, family
evaluation, and the Qwen Task A cross-phase finding.

Geometry verified programmatically (no overlaps, no overflow, footer
position exactly conserved) -- not visually rendered, no tooling
available for that. First draft, needs a human look before print.
</commit_message>
<xml_diff>
--- a/Sarcasm_Project_Poster.pptx
+++ b/Sarcasm_Project_Poster.pptx
@@ -3773,7 +3773,7 @@
         <p:spPr>
           <a:xfrm>
             <a:off x="0" y="9216000"/>
-            <a:ext cx="30276000" cy="624225"/>
+            <a:ext cx="30276000" cy="445875"/>
           </a:xfrm>
           <a:prstGeom prst="rect">
             <a:avLst/>
@@ -3817,8 +3817,8 @@
         </p:nvSpPr>
         <p:spPr>
           <a:xfrm>
-            <a:off x="648000" y="9301122"/>
-            <a:ext cx="28980000" cy="453982"/>
+            <a:off x="648000" y="9276801"/>
+            <a:ext cx="28980000" cy="324273"/>
           </a:xfrm>
           <a:prstGeom prst="rect">
             <a:avLst/>
@@ -3840,7 +3840,7 @@
               </a:spcAft>
             </a:pPr>
             <a:r>
-              <a:rPr sz="2975" b="1" i="0" dirty="0">
+              <a:rPr sz="2494" b="1" i="0" dirty="0">
                 <a:solidFill>
                   <a:srgbClr val="FFFFFF"/>
                 </a:solidFill>
@@ -3849,7 +3849,7 @@
               <a:t>PART I </a:t>
             </a:r>
             <a:r>
-              <a:rPr lang="en-IL" sz="2975" b="1" i="0" dirty="0">
+              <a:rPr lang="en-IL" sz="2494" b="1" i="0" dirty="0">
                 <a:solidFill>
                   <a:srgbClr val="FFFFFF"/>
                 </a:solidFill>
@@ -3858,7 +3858,7 @@
               <a:t>-</a:t>
             </a:r>
             <a:r>
-              <a:rPr sz="2975" b="1" i="0" dirty="0">
+              <a:rPr sz="2494" b="1" i="0" dirty="0">
                 <a:solidFill>
                   <a:srgbClr val="FFFFFF"/>
                 </a:solidFill>
@@ -3877,8 +3877,8 @@
         </p:nvSpPr>
         <p:spPr>
           <a:xfrm>
-            <a:off x="648000" y="10123963"/>
-            <a:ext cx="9276000" cy="283738"/>
+            <a:off x="648000" y="9864545"/>
+            <a:ext cx="9276000" cy="202670"/>
           </a:xfrm>
           <a:prstGeom prst="rect">
             <a:avLst/>
@@ -3900,7 +3900,7 @@
               </a:spcAft>
             </a:pPr>
             <a:r>
-              <a:rPr sz="2528" b="1" i="0">
+              <a:rPr sz="2120" b="1" i="0">
                 <a:solidFill>
                   <a:srgbClr val="0B2A4A"/>
                 </a:solidFill>
@@ -3919,8 +3919,8 @@
         </p:nvSpPr>
         <p:spPr>
           <a:xfrm>
-            <a:off x="648000" y="10634692"/>
-            <a:ext cx="9276000" cy="4096018"/>
+            <a:off x="648000" y="10229352"/>
+            <a:ext cx="9276000" cy="2925727"/>
           </a:xfrm>
           <a:prstGeom prst="rect">
             <a:avLst/>
@@ -3940,7 +3940,7 @@
               </a:spcAft>
             </a:pPr>
             <a:r>
-              <a:rPr sz="2007" dirty="0">
+              <a:rPr>
                 <a:solidFill>
                   <a:srgbClr val="4EB39A"/>
                 </a:solidFill>
@@ -3949,7 +3949,7 @@
               <a:t>■  </a:t>
             </a:r>
             <a:r>
-              <a:rPr sz="2007" b="1" dirty="0">
+              <a:rPr b="1">
                 <a:solidFill>
                   <a:srgbClr val="1A1A1A"/>
                 </a:solidFill>
@@ -3958,31 +3958,13 @@
               <a:t>Task: </a:t>
             </a:r>
             <a:r>
-              <a:rPr sz="2007" dirty="0">
-                <a:solidFill>
-                  <a:srgbClr val="1A1A1A"/>
-                </a:solidFill>
-                <a:latin typeface="Calibri"/>
-              </a:rPr>
-              <a:t>given a sarcastic tweet, generate a sincere rewrite preserving intended meaning </a:t>
-            </a:r>
-            <a:r>
-              <a:rPr lang="en-IL" sz="2007" dirty="0">
-                <a:solidFill>
-                  <a:srgbClr val="1A1A1A"/>
-                </a:solidFill>
-                <a:latin typeface="Calibri"/>
-              </a:rPr>
-              <a:t>-</a:t>
-            </a:r>
-            <a:r>
-              <a:rPr sz="2007" dirty="0">
-                <a:solidFill>
-                  <a:srgbClr val="1A1A1A"/>
-                </a:solidFill>
-                <a:latin typeface="Calibri"/>
-              </a:rPr>
-              <a:t> and test whether an LLM judge can validly replace human annotators.</a:t>
+              <a:rPr>
+                <a:solidFill>
+                  <a:srgbClr val="1A1A1A"/>
+                </a:solidFill>
+                <a:latin typeface="Calibri"/>
+              </a:rPr>
+              <a:t>generate a sincere rewrite of a sarcastic tweet and test whether an LLM judge can replace human annotators.</a:t>
             </a:r>
           </a:p>
           <a:p>
@@ -3995,7 +3977,7 @@
               </a:spcAft>
             </a:pPr>
             <a:r>
-              <a:rPr sz="2007" dirty="0">
+              <a:rPr>
                 <a:solidFill>
                   <a:srgbClr val="4EB39A"/>
                 </a:solidFill>
@@ -4004,40 +3986,22 @@
               <a:t>■  </a:t>
             </a:r>
             <a:r>
-              <a:rPr sz="2007" b="1" dirty="0">
-                <a:solidFill>
-                  <a:srgbClr val="1A1A1A"/>
-                </a:solidFill>
-                <a:latin typeface="Calibri"/>
-              </a:rPr>
-              <a:t>Dataset: </a:t>
-            </a:r>
-            <a:r>
-              <a:rPr sz="2007" dirty="0">
-                <a:solidFill>
-                  <a:srgbClr val="1A1A1A"/>
-                </a:solidFill>
-                <a:latin typeface="Calibri"/>
-              </a:rPr>
-              <a:t>the SIGN paper's </a:t>
-            </a:r>
-            <a:r>
-              <a:rPr sz="2007" dirty="0" err="1">
-                <a:solidFill>
-                  <a:srgbClr val="1A1A1A"/>
-                </a:solidFill>
-                <a:latin typeface="Calibri"/>
-              </a:rPr>
-              <a:t>sarcastictweet</a:t>
-            </a:r>
-            <a:r>
-              <a:rPr sz="2007" dirty="0">
-                <a:solidFill>
-                  <a:srgbClr val="1A1A1A"/>
-                </a:solidFill>
-                <a:latin typeface="Calibri"/>
-              </a:rPr>
-              <a:t> test set (Peled &amp; Reichart, 2017), deduplicated.</a:t>
+              <a:rPr b="1">
+                <a:solidFill>
+                  <a:srgbClr val="1A1A1A"/>
+                </a:solidFill>
+                <a:latin typeface="Calibri"/>
+              </a:rPr>
+              <a:t>Data &amp; models: </a:t>
+            </a:r>
+            <a:r>
+              <a:rPr>
+                <a:solidFill>
+                  <a:srgbClr val="1A1A1A"/>
+                </a:solidFill>
+                <a:latin typeface="Calibri"/>
+              </a:rPr>
+              <a:t>SIGN paper's test tweets (Peled &amp; Reichart, 2017); 5 candidates surveyed → 3 used (Gemini, Nvidia Nemotron, Liquid LFM), 4 prompt variants each.</a:t>
             </a:r>
           </a:p>
           <a:p>
@@ -4050,7 +4014,7 @@
               </a:spcAft>
             </a:pPr>
             <a:r>
-              <a:rPr sz="2007" dirty="0">
+              <a:rPr>
                 <a:solidFill>
                   <a:srgbClr val="4EB39A"/>
                 </a:solidFill>
@@ -4059,60 +4023,87 @@
               <a:t>■  </a:t>
             </a:r>
             <a:r>
-              <a:rPr sz="2007" b="1" dirty="0">
-                <a:solidFill>
-                  <a:srgbClr val="1A1A1A"/>
-                </a:solidFill>
-                <a:latin typeface="Calibri"/>
-              </a:rPr>
-              <a:t>Models: </a:t>
-            </a:r>
-            <a:r>
-              <a:rPr sz="2007" dirty="0">
-                <a:solidFill>
-                  <a:srgbClr val="1A1A1A"/>
-                </a:solidFill>
-                <a:latin typeface="Calibri"/>
-              </a:rPr>
-              <a:t>5 candidates surveyed → 3 used </a:t>
-            </a:r>
-            <a:r>
-              <a:rPr lang="en-IL" sz="2007" dirty="0">
-                <a:solidFill>
-                  <a:srgbClr val="1A1A1A"/>
-                </a:solidFill>
-                <a:latin typeface="Calibri"/>
-              </a:rPr>
-              <a:t>-</a:t>
-            </a:r>
-            <a:r>
-              <a:rPr sz="2007" dirty="0">
-                <a:solidFill>
-                  <a:srgbClr val="1A1A1A"/>
-                </a:solidFill>
-                <a:latin typeface="Calibri"/>
-              </a:rPr>
-              <a:t> Gemini 2.5 Flash Lite, Nvidia </a:t>
-            </a:r>
-            <a:r>
-              <a:rPr sz="2007" dirty="0" err="1">
-                <a:solidFill>
-                  <a:srgbClr val="1A1A1A"/>
-                </a:solidFill>
-                <a:latin typeface="Calibri"/>
-              </a:rPr>
-              <a:t>Nemotron</a:t>
-            </a:r>
-            <a:r>
-              <a:rPr sz="2007" dirty="0">
-                <a:solidFill>
-                  <a:srgbClr val="1A1A1A"/>
-                </a:solidFill>
-                <a:latin typeface="Calibri"/>
-              </a:rPr>
-              <a:t> Nano 9B v2, Liquid LFM 2.51.2B.</a:t>
-            </a:r>
-          </a:p>
+              <a:rPr b="1">
+                <a:solidFill>
+                  <a:srgbClr val="1A1A1A"/>
+                </a:solidFill>
+                <a:latin typeface="Calibri"/>
+              </a:rPr>
+              <a:t>Evaluation: </a:t>
+            </a:r>
+            <a:r>
+              <a:rPr>
+                <a:solidFill>
+                  <a:srgbClr val="1A1A1A"/>
+                </a:solidFill>
+                <a:latin typeface="Calibri"/>
+              </a:rPr>
+              <a:t>automatic metrics (BLEU/ROUGE/PINC), an LLM judge (GPT-OSS 20B, 1–3 scale), and 3 human annotators on 70 tweets.</a:t>
+            </a:r>
+          </a:p>
+        </p:txBody>
+      </p:sp>
+      <p:sp>
+        <p:nvSpPr>
+          <p:cNvPr id="16" name="TextBox 15"/>
+          <p:cNvSpPr txBox="1"/>
+          <p:nvPr/>
+        </p:nvSpPr>
+        <p:spPr>
+          <a:xfrm>
+            <a:off x="648000" y="13398283"/>
+            <a:ext cx="9276000" cy="202670"/>
+          </a:xfrm>
+          <a:prstGeom prst="rect">
+            <a:avLst/>
+          </a:prstGeom>
+          <a:noFill/>
+        </p:spPr>
+        <p:txBody>
+          <a:bodyPr wrap="square" lIns="0" tIns="0" rIns="0" bIns="0">
+            <a:spAutoFit/>
+          </a:bodyPr>
+          <a:lstStyle/>
+          <a:p>
+            <a:pPr algn="l">
+              <a:lnSpc>
+                <a:spcPct val="108000"/>
+              </a:lnSpc>
+              <a:spcAft>
+                <a:spcPts val="0"/>
+              </a:spcAft>
+            </a:pPr>
+            <a:r>
+              <a:rPr sz="2120" b="1" i="0">
+                <a:solidFill>
+                  <a:srgbClr val="0B2A4A"/>
+                </a:solidFill>
+                <a:latin typeface="Calibri"/>
+              </a:rPr>
+              <a:t>Statistical Validation</a:t>
+            </a:r>
+          </a:p>
+        </p:txBody>
+      </p:sp>
+      <p:sp>
+        <p:nvSpPr>
+          <p:cNvPr id="17" name="TextBox 16"/>
+          <p:cNvSpPr txBox="1"/>
+          <p:nvPr/>
+        </p:nvSpPr>
+        <p:spPr>
+          <a:xfrm>
+            <a:off x="648000" y="13763090"/>
+            <a:ext cx="9276000" cy="1928414"/>
+          </a:xfrm>
+          <a:prstGeom prst="rect">
+            <a:avLst/>
+          </a:prstGeom>
+          <a:noFill/>
+        </p:spPr>
+        <p:txBody>
+          <a:bodyPr wrap="square" lIns="0" tIns="0" rIns="0" bIns="0"/>
+          <a:lstStyle/>
           <a:p>
             <a:pPr algn="l">
               <a:lnSpc>
@@ -4123,7 +4114,7 @@
               </a:spcAft>
             </a:pPr>
             <a:r>
-              <a:rPr sz="2007" dirty="0">
+              <a:rPr>
                 <a:solidFill>
                   <a:srgbClr val="4EB39A"/>
                 </a:solidFill>
@@ -4132,58 +4123,22 @@
               <a:t>■  </a:t>
             </a:r>
             <a:r>
-              <a:rPr sz="2007" b="1" dirty="0">
-                <a:solidFill>
-                  <a:srgbClr val="1A1A1A"/>
-                </a:solidFill>
-                <a:latin typeface="Calibri"/>
-              </a:rPr>
-              <a:t>Prompts: </a:t>
-            </a:r>
-            <a:r>
-              <a:rPr sz="2007" dirty="0">
-                <a:solidFill>
-                  <a:srgbClr val="1A1A1A"/>
-                </a:solidFill>
-                <a:latin typeface="Calibri"/>
-              </a:rPr>
-              <a:t>4 variants (plain → “translate the true meaning” → </a:t>
-            </a:r>
-            <a:r>
-              <a:rPr sz="2007" dirty="0" err="1">
-                <a:solidFill>
-                  <a:srgbClr val="1A1A1A"/>
-                </a:solidFill>
-                <a:latin typeface="Calibri"/>
-              </a:rPr>
-              <a:t>formatconstrained</a:t>
-            </a:r>
-            <a:r>
-              <a:rPr sz="2007" dirty="0">
-                <a:solidFill>
-                  <a:srgbClr val="1A1A1A"/>
-                </a:solidFill>
-                <a:latin typeface="Calibri"/>
-              </a:rPr>
-              <a:t> → </a:t>
-            </a:r>
-            <a:r>
-              <a:rPr sz="2007" dirty="0" err="1">
-                <a:solidFill>
-                  <a:srgbClr val="1A1A1A"/>
-                </a:solidFill>
-                <a:latin typeface="Calibri"/>
-              </a:rPr>
-              <a:t>fewshot</a:t>
-            </a:r>
-            <a:r>
-              <a:rPr sz="2007" dirty="0">
-                <a:solidFill>
-                  <a:srgbClr val="1A1A1A"/>
-                </a:solidFill>
-                <a:latin typeface="Calibri"/>
-              </a:rPr>
-              <a:t>) × 3 models.</a:t>
+              <a:rPr b="1">
+                <a:solidFill>
+                  <a:srgbClr val="1A1A1A"/>
+                </a:solidFill>
+                <a:latin typeface="Calibri"/>
+              </a:rPr>
+              <a:t>Alt-Test: </a:t>
+            </a:r>
+            <a:r>
+              <a:rPr>
+                <a:solidFill>
+                  <a:srgbClr val="1A1A1A"/>
+                </a:solidFill>
+                <a:latin typeface="Calibri"/>
+              </a:rPr>
+              <a:t>leave-one-annotator-out test (Calderon et al., 2025) – Winning Rate 0.67, Advantage Probability 0.77 at ε=0.2 → PASSED.</a:t>
             </a:r>
           </a:p>
           <a:p>
@@ -4196,7 +4151,7 @@
               </a:spcAft>
             </a:pPr>
             <a:r>
-              <a:rPr sz="2007" dirty="0">
+              <a:rPr>
                 <a:solidFill>
                   <a:srgbClr val="4EB39A"/>
                 </a:solidFill>
@@ -4205,36 +4160,36 @@
               <a:t>■  </a:t>
             </a:r>
             <a:r>
-              <a:rPr sz="2007" b="1" dirty="0">
-                <a:solidFill>
-                  <a:srgbClr val="1A1A1A"/>
-                </a:solidFill>
-                <a:latin typeface="Calibri"/>
-              </a:rPr>
-              <a:t>Evaluation: </a:t>
-            </a:r>
-            <a:r>
-              <a:rPr sz="2007" dirty="0">
-                <a:solidFill>
-                  <a:srgbClr val="1A1A1A"/>
-                </a:solidFill>
-                <a:latin typeface="Calibri"/>
-              </a:rPr>
-              <a:t>automatic metrics (BLEU/ROUGE/PINC), an independent LLM judge (GPTOSS 20B, 1–3 scale), and 3 human annotators on a 70tweet sample.</a:t>
-            </a:r>
-          </a:p>
-        </p:txBody>
-      </p:sp>
-      <p:sp>
-        <p:nvSpPr>
-          <p:cNvPr id="16" name="TextBox 15"/>
+              <a:rPr b="1">
+                <a:solidFill>
+                  <a:srgbClr val="1A1A1A"/>
+                </a:solidFill>
+                <a:latin typeface="Calibri"/>
+              </a:rPr>
+              <a:t>Fleiss’ κ = 0.282: </a:t>
+            </a:r>
+            <a:r>
+              <a:rPr>
+                <a:solidFill>
+                  <a:srgbClr val="1A1A1A"/>
+                </a:solidFill>
+                <a:latin typeface="Calibri"/>
+              </a:rPr>
+              <a:t>“fair agreement” among human annotators – sarcasm translation is subjective even for people.</a:t>
+            </a:r>
+          </a:p>
+        </p:txBody>
+      </p:sp>
+      <p:sp>
+        <p:nvSpPr>
+          <p:cNvPr id="18" name="TextBox 17"/>
           <p:cNvSpPr txBox="1"/>
           <p:nvPr/>
         </p:nvSpPr>
         <p:spPr>
           <a:xfrm>
-            <a:off x="648000" y="15071197"/>
-            <a:ext cx="9276000" cy="283738"/>
+            <a:off x="10500000" y="9864545"/>
+            <a:ext cx="9276000" cy="202670"/>
           </a:xfrm>
           <a:prstGeom prst="rect">
             <a:avLst/>
@@ -4256,271 +4211,7 @@
               </a:spcAft>
             </a:pPr>
             <a:r>
-              <a:rPr sz="2528" b="1" i="0">
-                <a:solidFill>
-                  <a:srgbClr val="0B2A4A"/>
-                </a:solidFill>
-                <a:latin typeface="Calibri"/>
-              </a:rPr>
-              <a:t>Statistical Validation</a:t>
-            </a:r>
-          </a:p>
-        </p:txBody>
-      </p:sp>
-      <p:sp>
-        <p:nvSpPr>
-          <p:cNvPr id="17" name="TextBox 16"/>
-          <p:cNvSpPr txBox="1"/>
-          <p:nvPr/>
-        </p:nvSpPr>
-        <p:spPr>
-          <a:xfrm>
-            <a:off x="648000" y="15581926"/>
-            <a:ext cx="9276000" cy="2699780"/>
-          </a:xfrm>
-          <a:prstGeom prst="rect">
-            <a:avLst/>
-          </a:prstGeom>
-          <a:noFill/>
-        </p:spPr>
-        <p:txBody>
-          <a:bodyPr wrap="square" lIns="0" tIns="0" rIns="0" bIns="0"/>
-          <a:lstStyle/>
-          <a:p>
-            <a:pPr algn="l">
-              <a:lnSpc>
-                <a:spcPct val="110000"/>
-              </a:lnSpc>
-              <a:spcAft>
-                <a:spcPts val="700"/>
-              </a:spcAft>
-            </a:pPr>
-            <a:r>
-              <a:rPr sz="2007" dirty="0">
-                <a:solidFill>
-                  <a:srgbClr val="4EB39A"/>
-                </a:solidFill>
-                <a:latin typeface="Calibri"/>
-              </a:rPr>
-              <a:t>■  </a:t>
-            </a:r>
-            <a:r>
-              <a:rPr sz="2007" b="1" dirty="0" err="1">
-                <a:solidFill>
-                  <a:srgbClr val="1A1A1A"/>
-                </a:solidFill>
-                <a:latin typeface="Calibri"/>
-              </a:rPr>
-              <a:t>AltTest</a:t>
-            </a:r>
-            <a:r>
-              <a:rPr sz="2007" b="1" dirty="0">
-                <a:solidFill>
-                  <a:srgbClr val="1A1A1A"/>
-                </a:solidFill>
-                <a:latin typeface="Calibri"/>
-              </a:rPr>
-              <a:t> (Calderon et al., 2025): </a:t>
-            </a:r>
-            <a:r>
-              <a:rPr sz="2007" dirty="0" err="1">
-                <a:solidFill>
-                  <a:srgbClr val="1A1A1A"/>
-                </a:solidFill>
-                <a:latin typeface="Calibri"/>
-              </a:rPr>
-              <a:t>leaveoneannotatorout</a:t>
-            </a:r>
-            <a:r>
-              <a:rPr sz="2007" dirty="0">
-                <a:solidFill>
-                  <a:srgbClr val="1A1A1A"/>
-                </a:solidFill>
-                <a:latin typeface="Calibri"/>
-              </a:rPr>
-              <a:t> substitution test </a:t>
-            </a:r>
-            <a:r>
-              <a:rPr lang="en-IL" sz="2007" dirty="0">
-                <a:solidFill>
-                  <a:srgbClr val="1A1A1A"/>
-                </a:solidFill>
-                <a:latin typeface="Calibri"/>
-              </a:rPr>
-              <a:t>-</a:t>
-            </a:r>
-            <a:r>
-              <a:rPr sz="2007" dirty="0">
-                <a:solidFill>
-                  <a:srgbClr val="1A1A1A"/>
-                </a:solidFill>
-                <a:latin typeface="Calibri"/>
-              </a:rPr>
-              <a:t> Winning Rate 0.67, Advantage Probability 0.77 at </a:t>
-            </a:r>
-            <a:r>
-              <a:rPr sz="2007" dirty="0" err="1">
-                <a:solidFill>
-                  <a:srgbClr val="1A1A1A"/>
-                </a:solidFill>
-                <a:latin typeface="Calibri"/>
-              </a:rPr>
-              <a:t>ε</a:t>
-            </a:r>
-            <a:r>
-              <a:rPr sz="2007" dirty="0">
-                <a:solidFill>
-                  <a:srgbClr val="1A1A1A"/>
-                </a:solidFill>
-                <a:latin typeface="Calibri"/>
-              </a:rPr>
-              <a:t>=0.2 → PASSED.</a:t>
-            </a:r>
-          </a:p>
-          <a:p>
-            <a:pPr algn="l">
-              <a:lnSpc>
-                <a:spcPct val="110000"/>
-              </a:lnSpc>
-              <a:spcAft>
-                <a:spcPts val="700"/>
-              </a:spcAft>
-            </a:pPr>
-            <a:r>
-              <a:rPr sz="2007" dirty="0">
-                <a:solidFill>
-                  <a:srgbClr val="4EB39A"/>
-                </a:solidFill>
-                <a:latin typeface="Calibri"/>
-              </a:rPr>
-              <a:t>■  </a:t>
-            </a:r>
-            <a:r>
-              <a:rPr sz="2007" b="1" dirty="0">
-                <a:solidFill>
-                  <a:srgbClr val="1A1A1A"/>
-                </a:solidFill>
-                <a:latin typeface="Calibri"/>
-              </a:rPr>
-              <a:t>Fleiss’ Kappa = 0.282 </a:t>
-            </a:r>
-            <a:r>
-              <a:rPr sz="2007" dirty="0">
-                <a:solidFill>
-                  <a:srgbClr val="1A1A1A"/>
-                </a:solidFill>
-                <a:latin typeface="Calibri"/>
-              </a:rPr>
-              <a:t>(“fair agreement”) among the 3 human annotators </a:t>
-            </a:r>
-            <a:r>
-              <a:rPr lang="en-IL" sz="2007" dirty="0">
-                <a:solidFill>
-                  <a:srgbClr val="1A1A1A"/>
-                </a:solidFill>
-                <a:latin typeface="Calibri"/>
-              </a:rPr>
-              <a:t>-</a:t>
-            </a:r>
-            <a:r>
-              <a:rPr sz="2007" dirty="0">
-                <a:solidFill>
-                  <a:srgbClr val="1A1A1A"/>
-                </a:solidFill>
-                <a:latin typeface="Calibri"/>
-              </a:rPr>
-              <a:t> </a:t>
-            </a:r>
-            <a:r>
-              <a:rPr sz="2007" dirty="0" err="1">
-                <a:solidFill>
-                  <a:srgbClr val="1A1A1A"/>
-                </a:solidFill>
-                <a:latin typeface="Calibri"/>
-              </a:rPr>
-              <a:t>sarcasmtranslation</a:t>
-            </a:r>
-            <a:r>
-              <a:rPr sz="2007" dirty="0">
-                <a:solidFill>
-                  <a:srgbClr val="1A1A1A"/>
-                </a:solidFill>
-                <a:latin typeface="Calibri"/>
-              </a:rPr>
-              <a:t> quality is subjective even for humans.</a:t>
-            </a:r>
-          </a:p>
-          <a:p>
-            <a:pPr algn="l">
-              <a:lnSpc>
-                <a:spcPct val="110000"/>
-              </a:lnSpc>
-              <a:spcAft>
-                <a:spcPts val="700"/>
-              </a:spcAft>
-            </a:pPr>
-            <a:r>
-              <a:rPr sz="2007" dirty="0">
-                <a:solidFill>
-                  <a:srgbClr val="4EB39A"/>
-                </a:solidFill>
-                <a:latin typeface="Calibri"/>
-              </a:rPr>
-              <a:t>■  </a:t>
-            </a:r>
-            <a:r>
-              <a:rPr sz="2007" b="1" dirty="0">
-                <a:solidFill>
-                  <a:srgbClr val="1A1A1A"/>
-                </a:solidFill>
-                <a:latin typeface="Calibri"/>
-              </a:rPr>
-              <a:t>Kruskal–Wallis: </a:t>
-            </a:r>
-            <a:r>
-              <a:rPr sz="2007" dirty="0">
-                <a:solidFill>
-                  <a:srgbClr val="1A1A1A"/>
-                </a:solidFill>
-                <a:latin typeface="Calibri"/>
-              </a:rPr>
-              <a:t>both prompt choice (p=9.4×10⁻³⁴) and model choice (p=5.1×10⁻⁷²) have a statistically decisive effect on quality.</a:t>
-            </a:r>
-          </a:p>
-        </p:txBody>
-      </p:sp>
-      <p:sp>
-        <p:nvSpPr>
-          <p:cNvPr id="18" name="TextBox 17"/>
-          <p:cNvSpPr txBox="1"/>
-          <p:nvPr/>
-        </p:nvSpPr>
-        <p:spPr>
-          <a:xfrm>
-            <a:off x="10500000" y="10123963"/>
-            <a:ext cx="9276000" cy="283738"/>
-          </a:xfrm>
-          <a:prstGeom prst="rect">
-            <a:avLst/>
-          </a:prstGeom>
-          <a:noFill/>
-        </p:spPr>
-        <p:txBody>
-          <a:bodyPr wrap="square" lIns="0" tIns="0" rIns="0" bIns="0">
-            <a:spAutoFit/>
-          </a:bodyPr>
-          <a:lstStyle/>
-          <a:p>
-            <a:pPr algn="l">
-              <a:lnSpc>
-                <a:spcPct val="108000"/>
-              </a:lnSpc>
-              <a:spcAft>
-                <a:spcPts val="0"/>
-              </a:spcAft>
-            </a:pPr>
-            <a:r>
-              <a:rPr sz="2528" b="1" i="0">
+              <a:rPr sz="2120" b="1" i="0">
                 <a:solidFill>
                   <a:srgbClr val="0B2A4A"/>
                 </a:solidFill>
@@ -4547,8 +4238,8 @@
         </p:blipFill>
         <p:spPr>
           <a:xfrm>
-            <a:off x="10500000" y="10634692"/>
-            <a:ext cx="4530000" cy="2294350"/>
+            <a:off x="10500000" y="10229352"/>
+            <a:ext cx="4530000" cy="2911012"/>
           </a:xfrm>
           <a:prstGeom prst="rect">
             <a:avLst/>
@@ -4568,8 +4259,8 @@
         </p:nvSpPr>
         <p:spPr>
           <a:xfrm>
-            <a:off x="10500000" y="13014164"/>
-            <a:ext cx="4530000" cy="232875"/>
+            <a:off x="10500000" y="13160364"/>
+            <a:ext cx="4530000" cy="180000"/>
           </a:xfrm>
           <a:prstGeom prst="rect">
             <a:avLst/>
@@ -4591,7 +4282,7 @@
               </a:spcAft>
             </a:pPr>
             <a:r>
-              <a:rPr sz="1561" b="0" i="1" dirty="0">
+              <a:rPr sz="1309" b="0" i="1" dirty="0">
                 <a:solidFill>
                   <a:srgbClr val="555555"/>
                 </a:solidFill>
@@ -4600,7 +4291,7 @@
               <a:t>Fig. 1 </a:t>
             </a:r>
             <a:r>
-              <a:rPr lang="en-IL" sz="1561" b="0" i="1" dirty="0">
+              <a:rPr lang="en-IL" sz="1309" b="0" i="1" dirty="0">
                 <a:solidFill>
                   <a:srgbClr val="555555"/>
                 </a:solidFill>
@@ -4609,7 +4300,7 @@
               <a:t>-</a:t>
             </a:r>
             <a:r>
-              <a:rPr sz="1561" b="0" i="1" dirty="0">
+              <a:rPr sz="1309" b="0" i="1" dirty="0">
                 <a:solidFill>
                   <a:srgbClr val="555555"/>
                 </a:solidFill>
@@ -4618,7 +4309,7 @@
               <a:t> Human vs. </a:t>
             </a:r>
             <a:r>
-              <a:rPr sz="1561" b="0" i="1" dirty="0" err="1">
+              <a:rPr sz="1309" b="0" i="1" dirty="0" err="1">
                 <a:solidFill>
                   <a:srgbClr val="555555"/>
                 </a:solidFill>
@@ -4627,120 +4318,13 @@
               <a:t>LLMjudge</a:t>
             </a:r>
             <a:r>
-              <a:rPr sz="1561" b="0" i="1" dirty="0">
+              <a:rPr sz="1309" b="0" i="1" dirty="0">
                 <a:solidFill>
                   <a:srgbClr val="555555"/>
                 </a:solidFill>
                 <a:latin typeface="Calibri"/>
               </a:rPr>
               <a:t> score, by model</a:t>
-            </a:r>
-          </a:p>
-        </p:txBody>
-      </p:sp>
-      <p:pic>
-        <p:nvPicPr>
-          <p:cNvPr id="21" name="Picture 20" descr="2_prompts_comparison.png"/>
-          <p:cNvPicPr>
-            <a:picLocks noChangeAspect="1"/>
-          </p:cNvPicPr>
-          <p:nvPr/>
-        </p:nvPicPr>
-        <p:blipFill>
-          <a:blip r:embed="rId3"/>
-          <a:stretch>
-            <a:fillRect/>
-          </a:stretch>
-        </p:blipFill>
-        <p:spPr>
-          <a:xfrm>
-            <a:off x="15246000" y="10634692"/>
-            <a:ext cx="4530000" cy="2294350"/>
-          </a:xfrm>
-          <a:prstGeom prst="rect">
-            <a:avLst/>
-          </a:prstGeom>
-          <a:ln w="9525">
-            <a:solidFill>
-              <a:srgbClr val="DDDDDD"/>
-            </a:solidFill>
-          </a:ln>
-        </p:spPr>
-      </p:pic>
-      <p:sp>
-        <p:nvSpPr>
-          <p:cNvPr id="22" name="TextBox 21"/>
-          <p:cNvSpPr txBox="1"/>
-          <p:nvPr/>
-        </p:nvSpPr>
-        <p:spPr>
-          <a:xfrm>
-            <a:off x="15246000" y="13014164"/>
-            <a:ext cx="4530000" cy="232875"/>
-          </a:xfrm>
-          <a:prstGeom prst="rect">
-            <a:avLst/>
-          </a:prstGeom>
-          <a:noFill/>
-        </p:spPr>
-        <p:txBody>
-          <a:bodyPr wrap="square" lIns="0" tIns="0" rIns="0" bIns="0">
-            <a:spAutoFit/>
-          </a:bodyPr>
-          <a:lstStyle/>
-          <a:p>
-            <a:pPr algn="l">
-              <a:lnSpc>
-                <a:spcPct val="110000"/>
-              </a:lnSpc>
-              <a:spcAft>
-                <a:spcPts val="0"/>
-              </a:spcAft>
-            </a:pPr>
-            <a:r>
-              <a:rPr sz="1561" b="0" i="1" dirty="0">
-                <a:solidFill>
-                  <a:srgbClr val="555555"/>
-                </a:solidFill>
-                <a:latin typeface="Calibri"/>
-              </a:rPr>
-              <a:t>Fig. 2 </a:t>
-            </a:r>
-            <a:r>
-              <a:rPr lang="en-IL" sz="1561" b="0" i="1" dirty="0">
-                <a:solidFill>
-                  <a:srgbClr val="555555"/>
-                </a:solidFill>
-                <a:latin typeface="Calibri"/>
-              </a:rPr>
-              <a:t>-</a:t>
-            </a:r>
-            <a:r>
-              <a:rPr sz="1561" b="0" i="1" dirty="0">
-                <a:solidFill>
-                  <a:srgbClr val="555555"/>
-                </a:solidFill>
-                <a:latin typeface="Calibri"/>
-              </a:rPr>
-              <a:t> Human vs. </a:t>
-            </a:r>
-            <a:r>
-              <a:rPr sz="1561" b="0" i="1" dirty="0" err="1">
-                <a:solidFill>
-                  <a:srgbClr val="555555"/>
-                </a:solidFill>
-                <a:latin typeface="Calibri"/>
-              </a:rPr>
-              <a:t>LLMjudge</a:t>
-            </a:r>
-            <a:r>
-              <a:rPr sz="1561" b="0" i="1" dirty="0">
-                <a:solidFill>
-                  <a:srgbClr val="555555"/>
-                </a:solidFill>
-                <a:latin typeface="Calibri"/>
-              </a:rPr>
-              <a:t> score, by prompt</a:t>
             </a:r>
           </a:p>
         </p:txBody>
@@ -4761,8 +4345,8 @@
         </p:blipFill>
         <p:spPr>
           <a:xfrm>
-            <a:off x="10500000" y="13865380"/>
-            <a:ext cx="4530000" cy="2687684"/>
+            <a:off x="15246000" y="10229352"/>
+            <a:ext cx="4530000" cy="3410063"/>
           </a:xfrm>
           <a:prstGeom prst="rect">
             <a:avLst/>
@@ -4782,8 +4366,8 @@
         </p:nvSpPr>
         <p:spPr>
           <a:xfrm>
-            <a:off x="10500000" y="16638185"/>
-            <a:ext cx="4530000" cy="477980"/>
+            <a:off x="15246000" y="13659415"/>
+            <a:ext cx="4530000" cy="340000"/>
           </a:xfrm>
           <a:prstGeom prst="rect">
             <a:avLst/>
@@ -4805,7 +4389,7 @@
               </a:spcAft>
             </a:pPr>
             <a:r>
-              <a:rPr sz="1561" b="0" i="1" dirty="0">
+              <a:rPr sz="1309" b="0" i="1" dirty="0">
                 <a:solidFill>
                   <a:srgbClr val="555555"/>
                 </a:solidFill>
@@ -4814,7 +4398,7 @@
               <a:t>Fig. 3 </a:t>
             </a:r>
             <a:r>
-              <a:rPr lang="en-IL" sz="1561" b="0" i="1" dirty="0">
+              <a:rPr lang="en-IL" sz="1309" b="0" i="1" dirty="0">
                 <a:solidFill>
                   <a:srgbClr val="555555"/>
                 </a:solidFill>
@@ -4823,7 +4407,7 @@
               <a:t>-</a:t>
             </a:r>
             <a:r>
-              <a:rPr sz="1561" b="0" i="1" dirty="0">
+              <a:rPr sz="1309" b="0" i="1" dirty="0">
                 <a:solidFill>
                   <a:srgbClr val="555555"/>
                 </a:solidFill>
@@ -4832,7 +4416,7 @@
               <a:t> Confusion matrix: human vs. </a:t>
             </a:r>
             <a:r>
-              <a:rPr sz="1561" b="0" i="1" dirty="0" err="1">
+              <a:rPr sz="1309" b="0" i="1" dirty="0" err="1">
                 <a:solidFill>
                   <a:srgbClr val="555555"/>
                 </a:solidFill>
@@ -4841,102 +4425,13 @@
               <a:t>LLMjudge</a:t>
             </a:r>
             <a:r>
-              <a:rPr sz="1561" b="0" i="1" dirty="0">
+              <a:rPr sz="1309" b="0" i="1" dirty="0">
                 <a:solidFill>
                   <a:srgbClr val="555555"/>
                 </a:solidFill>
                 <a:latin typeface="Calibri"/>
               </a:rPr>
               <a:t> score</a:t>
-            </a:r>
-          </a:p>
-        </p:txBody>
-      </p:sp>
-      <p:pic>
-        <p:nvPicPr>
-          <p:cNvPr id="25" name="Picture 24" descr="linguistic_2_overlap_boxplot.png"/>
-          <p:cNvPicPr>
-            <a:picLocks noChangeAspect="1"/>
-          </p:cNvPicPr>
-          <p:nvPr/>
-        </p:nvPicPr>
-        <p:blipFill>
-          <a:blip r:embed="rId5"/>
-          <a:stretch>
-            <a:fillRect/>
-          </a:stretch>
-        </p:blipFill>
-        <p:spPr>
-          <a:xfrm>
-            <a:off x="15246000" y="13865380"/>
-            <a:ext cx="4530000" cy="2126049"/>
-          </a:xfrm>
-          <a:prstGeom prst="rect">
-            <a:avLst/>
-          </a:prstGeom>
-          <a:ln w="9525">
-            <a:solidFill>
-              <a:srgbClr val="DDDDDD"/>
-            </a:solidFill>
-          </a:ln>
-        </p:spPr>
-      </p:pic>
-      <p:sp>
-        <p:nvSpPr>
-          <p:cNvPr id="26" name="TextBox 25"/>
-          <p:cNvSpPr txBox="1"/>
-          <p:nvPr/>
-        </p:nvSpPr>
-        <p:spPr>
-          <a:xfrm>
-            <a:off x="15246000" y="16076550"/>
-            <a:ext cx="4530000" cy="477980"/>
-          </a:xfrm>
-          <a:prstGeom prst="rect">
-            <a:avLst/>
-          </a:prstGeom>
-          <a:noFill/>
-        </p:spPr>
-        <p:txBody>
-          <a:bodyPr wrap="square" lIns="0" tIns="0" rIns="0" bIns="0">
-            <a:spAutoFit/>
-          </a:bodyPr>
-          <a:lstStyle/>
-          <a:p>
-            <a:pPr algn="l">
-              <a:lnSpc>
-                <a:spcPct val="110000"/>
-              </a:lnSpc>
-              <a:spcAft>
-                <a:spcPts val="0"/>
-              </a:spcAft>
-            </a:pPr>
-            <a:r>
-              <a:rPr sz="1561" b="0" i="1" dirty="0">
-                <a:solidFill>
-                  <a:srgbClr val="555555"/>
-                </a:solidFill>
-                <a:latin typeface="Calibri"/>
-              </a:rPr>
-              <a:t>Fig. 4 </a:t>
-            </a:r>
-            <a:r>
-              <a:rPr lang="en-IL" sz="1561" b="0" i="1" dirty="0">
-                <a:solidFill>
-                  <a:srgbClr val="555555"/>
-                </a:solidFill>
-                <a:latin typeface="Calibri"/>
-              </a:rPr>
-              <a:t>-</a:t>
-            </a:r>
-            <a:r>
-              <a:rPr sz="1561" b="0" i="1" dirty="0">
-                <a:solidFill>
-                  <a:srgbClr val="555555"/>
-                </a:solidFill>
-                <a:latin typeface="Calibri"/>
-              </a:rPr>
-              <a:t> Word overlap with source, by prompt &amp; model</a:t>
             </a:r>
           </a:p>
         </p:txBody>
@@ -4949,8 +4444,8 @@
         </p:nvSpPr>
         <p:spPr>
           <a:xfrm>
-            <a:off x="20352000" y="10123963"/>
-            <a:ext cx="9276000" cy="283738"/>
+            <a:off x="20352000" y="9864545"/>
+            <a:ext cx="9276000" cy="202670"/>
           </a:xfrm>
           <a:prstGeom prst="rect">
             <a:avLst/>
@@ -4972,7 +4467,7 @@
               </a:spcAft>
             </a:pPr>
             <a:r>
-              <a:rPr sz="2528" b="1" i="0">
+              <a:rPr sz="2120" b="1" i="0">
                 <a:solidFill>
                   <a:srgbClr val="0B2A4A"/>
                 </a:solidFill>
@@ -4991,8 +4486,8 @@
         </p:nvSpPr>
         <p:spPr>
           <a:xfrm>
-            <a:off x="20352000" y="10634692"/>
-            <a:ext cx="9276000" cy="3700610"/>
+            <a:off x="20352000" y="10229352"/>
+            <a:ext cx="9276000" cy="2643293"/>
           </a:xfrm>
           <a:prstGeom prst="rect">
             <a:avLst/>
@@ -5012,7 +4507,7 @@
               </a:spcAft>
             </a:pPr>
             <a:r>
-              <a:rPr sz="2007" dirty="0">
+              <a:rPr>
                 <a:solidFill>
                   <a:srgbClr val="4EB39A"/>
                 </a:solidFill>
@@ -5021,7 +4516,7 @@
               <a:t>■  </a:t>
             </a:r>
             <a:r>
-              <a:rPr sz="2007" b="1" dirty="0">
+              <a:rPr b="1">
                 <a:solidFill>
                   <a:srgbClr val="1A1A1A"/>
                 </a:solidFill>
@@ -5030,31 +4525,13 @@
               <a:t>Best model: </a:t>
             </a:r>
             <a:r>
-              <a:rPr sz="2007" dirty="0">
-                <a:solidFill>
-                  <a:srgbClr val="1A1A1A"/>
-                </a:solidFill>
-                <a:latin typeface="Calibri"/>
-              </a:rPr>
-              <a:t>Nvidia led </a:t>
-            </a:r>
-            <a:r>
-              <a:rPr sz="2007" dirty="0" err="1">
-                <a:solidFill>
-                  <a:srgbClr val="1A1A1A"/>
-                </a:solidFill>
-                <a:latin typeface="Calibri"/>
-              </a:rPr>
-              <a:t>humanrated</a:t>
-            </a:r>
-            <a:r>
-              <a:rPr sz="2007" dirty="0">
-                <a:solidFill>
-                  <a:srgbClr val="1A1A1A"/>
-                </a:solidFill>
-                <a:latin typeface="Calibri"/>
-              </a:rPr>
-              <a:t> quality (~2.25/3), Gemini a close second, Liquid a distant last (~1.3).</a:t>
+              <a:rPr>
+                <a:solidFill>
+                  <a:srgbClr val="1A1A1A"/>
+                </a:solidFill>
+                <a:latin typeface="Calibri"/>
+              </a:rPr>
+              <a:t>Nvidia led human-rated quality (~2.25/3), Gemini close second, Liquid a distant last (~1.3).</a:t>
             </a:r>
           </a:p>
           <a:p>
@@ -5067,7 +4544,7 @@
               </a:spcAft>
             </a:pPr>
             <a:r>
-              <a:rPr sz="2007" dirty="0">
+              <a:rPr>
                 <a:solidFill>
                   <a:srgbClr val="4EB39A"/>
                 </a:solidFill>
@@ -5076,7 +4553,7 @@
               <a:t>■  </a:t>
             </a:r>
             <a:r>
-              <a:rPr sz="2007" b="1" dirty="0">
+              <a:rPr b="1">
                 <a:solidFill>
                   <a:srgbClr val="1A1A1A"/>
                 </a:solidFill>
@@ -5085,31 +4562,13 @@
               <a:t>Rewriting strategies: </a:t>
             </a:r>
             <a:r>
-              <a:rPr sz="2007" dirty="0">
-                <a:solidFill>
-                  <a:srgbClr val="1A1A1A"/>
-                </a:solidFill>
-                <a:latin typeface="Calibri"/>
-              </a:rPr>
-              <a:t>Gemini = “explanatory expansion”; Nvidia = “stable precision”; Liquid = “unstable reduction” (~85% PINC, </a:t>
-            </a:r>
-            <a:r>
-              <a:rPr sz="2007" dirty="0" err="1">
-                <a:solidFill>
-                  <a:srgbClr val="1A1A1A"/>
-                </a:solidFill>
-                <a:latin typeface="Calibri"/>
-              </a:rPr>
-              <a:t>nearzero</a:t>
-            </a:r>
-            <a:r>
-              <a:rPr sz="2007" dirty="0">
-                <a:solidFill>
-                  <a:srgbClr val="1A1A1A"/>
-                </a:solidFill>
-                <a:latin typeface="Calibri"/>
-              </a:rPr>
-              <a:t> source overlap).</a:t>
+              <a:rPr>
+                <a:solidFill>
+                  <a:srgbClr val="1A1A1A"/>
+                </a:solidFill>
+                <a:latin typeface="Calibri"/>
+              </a:rPr>
+              <a:t>Gemini = explanatory expansion; Nvidia = stable precision; Liquid = unstable reduction (near-zero source overlap).</a:t>
             </a:r>
           </a:p>
           <a:p>
@@ -5122,7 +4581,7 @@
               </a:spcAft>
             </a:pPr>
             <a:r>
-              <a:rPr sz="2007" dirty="0">
+              <a:rPr>
                 <a:solidFill>
                   <a:srgbClr val="4EB39A"/>
                 </a:solidFill>
@@ -5131,113 +4590,22 @@
               <a:t>■  </a:t>
             </a:r>
             <a:r>
-              <a:rPr sz="2007" b="1" dirty="0">
-                <a:solidFill>
-                  <a:srgbClr val="1A1A1A"/>
-                </a:solidFill>
-                <a:latin typeface="Calibri"/>
-              </a:rPr>
-              <a:t>Judge vs. human agreement: </a:t>
-            </a:r>
-            <a:r>
-              <a:rPr sz="2007" dirty="0">
-                <a:solidFill>
-                  <a:srgbClr val="1A1A1A"/>
-                </a:solidFill>
-                <a:latin typeface="Calibri"/>
-              </a:rPr>
-              <a:t>67.1% (Liquid) down to 31.4% (Nvidia) </a:t>
-            </a:r>
-            <a:r>
-              <a:rPr lang="en-IL" sz="2007" dirty="0">
-                <a:solidFill>
-                  <a:srgbClr val="1A1A1A"/>
-                </a:solidFill>
-                <a:latin typeface="Calibri"/>
-              </a:rPr>
-              <a:t>-</a:t>
-            </a:r>
-            <a:r>
-              <a:rPr sz="2007" dirty="0">
-                <a:solidFill>
-                  <a:srgbClr val="1A1A1A"/>
-                </a:solidFill>
-                <a:latin typeface="Calibri"/>
-              </a:rPr>
-              <a:t> easy to agree on outright failure, hard to agree on nuanced quality.</a:t>
-            </a:r>
-          </a:p>
-          <a:p>
-            <a:pPr algn="l">
-              <a:lnSpc>
-                <a:spcPct val="110000"/>
-              </a:lnSpc>
-              <a:spcAft>
-                <a:spcPts val="700"/>
-              </a:spcAft>
-            </a:pPr>
-            <a:r>
-              <a:rPr sz="2007" dirty="0">
-                <a:solidFill>
-                  <a:srgbClr val="4EB39A"/>
-                </a:solidFill>
-                <a:latin typeface="Calibri"/>
-              </a:rPr>
-              <a:t>■  </a:t>
-            </a:r>
-            <a:r>
-              <a:rPr sz="2007" b="1" dirty="0">
-                <a:solidFill>
-                  <a:srgbClr val="1A1A1A"/>
-                </a:solidFill>
-                <a:latin typeface="Calibri"/>
-              </a:rPr>
-              <a:t>Judge biases found: </a:t>
-            </a:r>
-            <a:r>
-              <a:rPr sz="2007" dirty="0">
-                <a:solidFill>
-                  <a:srgbClr val="1A1A1A"/>
-                </a:solidFill>
-                <a:latin typeface="Calibri"/>
-              </a:rPr>
-              <a:t>semantic rigidity (penalizes </a:t>
-            </a:r>
-            <a:r>
-              <a:rPr sz="2007" dirty="0" err="1">
-                <a:solidFill>
-                  <a:srgbClr val="1A1A1A"/>
-                </a:solidFill>
-                <a:latin typeface="Calibri"/>
-              </a:rPr>
-              <a:t>creativebutcorrect</a:t>
-            </a:r>
-            <a:r>
-              <a:rPr sz="2007" dirty="0">
-                <a:solidFill>
-                  <a:srgbClr val="1A1A1A"/>
-                </a:solidFill>
-                <a:latin typeface="Calibri"/>
-              </a:rPr>
-              <a:t> paraphrases) and fluency bias (rewards </a:t>
-            </a:r>
-            <a:r>
-              <a:rPr sz="2007" dirty="0" err="1">
-                <a:solidFill>
-                  <a:srgbClr val="1A1A1A"/>
-                </a:solidFill>
-                <a:latin typeface="Calibri"/>
-              </a:rPr>
-              <a:t>fluentbutwrong</a:t>
-            </a:r>
-            <a:r>
-              <a:rPr sz="2007" dirty="0">
-                <a:solidFill>
-                  <a:srgbClr val="1A1A1A"/>
-                </a:solidFill>
-                <a:latin typeface="Calibri"/>
-              </a:rPr>
-              <a:t> text).</a:t>
+              <a:rPr b="1">
+                <a:solidFill>
+                  <a:srgbClr val="1A1A1A"/>
+                </a:solidFill>
+                <a:latin typeface="Calibri"/>
+              </a:rPr>
+              <a:t>Judge vs. human: </a:t>
+            </a:r>
+            <a:r>
+              <a:rPr>
+                <a:solidFill>
+                  <a:srgbClr val="1A1A1A"/>
+                </a:solidFill>
+                <a:latin typeface="Calibri"/>
+              </a:rPr>
+              <a:t>67.1% agreement on outright failures down to 31.4% on nuanced quality – semantic rigidity &amp; fluency bias found.</a:t>
             </a:r>
           </a:p>
         </p:txBody>
@@ -5250,8 +4618,8 @@
         </p:nvSpPr>
         <p:spPr>
           <a:xfrm>
-            <a:off x="20352000" y="14675789"/>
-            <a:ext cx="9276000" cy="283738"/>
+            <a:off x="20352000" y="13115849"/>
+            <a:ext cx="9276000" cy="202670"/>
           </a:xfrm>
           <a:prstGeom prst="rect">
             <a:avLst/>
@@ -5273,7 +4641,7 @@
               </a:spcAft>
             </a:pPr>
             <a:r>
-              <a:rPr sz="2528" b="1" i="0">
+              <a:rPr sz="2120" b="1" i="0">
                 <a:solidFill>
                   <a:srgbClr val="0B2A4A"/>
                 </a:solidFill>
@@ -5292,8 +4660,8 @@
         </p:nvSpPr>
         <p:spPr>
           <a:xfrm>
-            <a:off x="20352000" y="15186518"/>
-            <a:ext cx="9276000" cy="1373699"/>
+            <a:off x="20352000" y="13480656"/>
+            <a:ext cx="9276000" cy="981213"/>
           </a:xfrm>
           <a:prstGeom prst="rect">
             <a:avLst/>
@@ -5315,49 +4683,13 @@
               </a:spcAft>
             </a:pPr>
             <a:r>
-              <a:rPr sz="2007" b="0" i="0" dirty="0">
-                <a:solidFill>
-                  <a:srgbClr val="1A1A1A"/>
-                </a:solidFill>
-                <a:latin typeface="Calibri"/>
-              </a:rPr>
-              <a:t>Across the case studies and error analysis, the recurring failure was models not recognizing sarcasm in the first place </a:t>
-            </a:r>
-            <a:r>
-              <a:rPr lang="en-IL" sz="2007" b="0" i="0" dirty="0">
-                <a:solidFill>
-                  <a:srgbClr val="1A1A1A"/>
-                </a:solidFill>
-                <a:latin typeface="Calibri"/>
-              </a:rPr>
-              <a:t>-</a:t>
-            </a:r>
-            <a:r>
-              <a:rPr sz="2007" b="0" i="0" dirty="0">
-                <a:solidFill>
-                  <a:srgbClr val="1A1A1A"/>
-                </a:solidFill>
-                <a:latin typeface="Calibri"/>
-              </a:rPr>
-              <a:t> no </a:t>
-            </a:r>
-            <a:r>
-              <a:rPr sz="2007" b="0" i="0" dirty="0" err="1">
-                <a:solidFill>
-                  <a:srgbClr val="1A1A1A"/>
-                </a:solidFill>
-                <a:latin typeface="Calibri"/>
-              </a:rPr>
-              <a:t>rewritingprompt</a:t>
-            </a:r>
-            <a:r>
-              <a:rPr sz="2007" b="0" i="0" dirty="0">
-                <a:solidFill>
-                  <a:srgbClr val="1A1A1A"/>
-                </a:solidFill>
-                <a:latin typeface="Calibri"/>
-              </a:rPr>
-              <a:t> refinement fixes a misread input. This motivated Part II: treat detection as its own dedicated, rigorously compared problem.</a:t>
+              <a:rPr sz="1683" b="0" i="0" dirty="0">
+                <a:solidFill>
+                  <a:srgbClr val="1A1A1A"/>
+                </a:solidFill>
+                <a:latin typeface="Calibri"/>
+              </a:rPr>
+              <a:t>The recurring failure was models not recognizing sarcasm in the first place – no rewriting-prompt fix helps a misread input. This motivated Part II: treat detection as its own rigorously-compared problem.</a:t>
             </a:r>
           </a:p>
         </p:txBody>
@@ -5370,8 +4702,8 @@
         </p:nvSpPr>
         <p:spPr>
           <a:xfrm>
-            <a:off x="0" y="19019426"/>
-            <a:ext cx="30276000" cy="926017"/>
+            <a:off x="0" y="16218447"/>
+            <a:ext cx="30276000" cy="569857"/>
           </a:xfrm>
           <a:prstGeom prst="rect">
             <a:avLst/>
@@ -5415,8 +4747,8 @@
         </p:nvSpPr>
         <p:spPr>
           <a:xfrm>
-            <a:off x="648000" y="19145701"/>
-            <a:ext cx="28980000" cy="673467"/>
+            <a:off x="648000" y="16296155"/>
+            <a:ext cx="28980000" cy="414441"/>
           </a:xfrm>
           <a:prstGeom prst="rect">
             <a:avLst/>
@@ -5438,7 +4770,7 @@
               </a:spcAft>
             </a:pPr>
             <a:r>
-              <a:rPr sz="3710" b="1" i="0" dirty="0">
+              <a:rPr sz="2820" b="1" i="0" dirty="0">
                 <a:solidFill>
                   <a:srgbClr val="FFFFFF"/>
                 </a:solidFill>
@@ -5447,7 +4779,7 @@
               <a:t>PART II </a:t>
             </a:r>
             <a:r>
-              <a:rPr lang="en-IL" sz="3710" b="1" i="0" dirty="0">
+              <a:rPr lang="en-IL" sz="2820" b="1" i="0" dirty="0">
                 <a:solidFill>
                   <a:srgbClr val="FFFFFF"/>
                 </a:solidFill>
@@ -5456,7 +4788,7 @@
               <a:t>-</a:t>
             </a:r>
             <a:r>
-              <a:rPr sz="3710" b="1" i="0" dirty="0">
+              <a:rPr sz="2820" b="1" i="0" dirty="0">
                 <a:solidFill>
                   <a:srgbClr val="FFFFFF"/>
                 </a:solidFill>
@@ -5476,8 +4808,8 @@
           <p:nvPr/>
         </p:nvGraphicFramePr>
         <p:xfrm>
-          <a:off x="648000" y="20282177"/>
-          <a:ext cx="28979998" cy="3998711"/>
+          <a:off x="648000" y="16995524"/>
+          <a:ext cx="28979998" cy="2460747"/>
         </p:xfrm>
         <a:graphic>
           <a:graphicData uri="http://schemas.openxmlformats.org/drawingml/2006/table">
@@ -5508,7 +4840,7 @@
                   </a:extLst>
                 </a:gridCol>
               </a:tblGrid>
-              <a:tr h="571244">
+              <a:tr h="351535">
                 <a:tc>
                   <a:txBody>
                     <a:bodyPr/>
@@ -5516,7 +4848,7 @@
                     <a:p>
                       <a:pPr algn="l"/>
                       <a:r>
-                        <a:rPr sz="2689" b="1" dirty="0">
+                        <a:rPr sz="2044" b="1" dirty="0">
                           <a:solidFill>
                             <a:srgbClr val="FFFFFF"/>
                           </a:solidFill>
@@ -5538,7 +4870,7 @@
                     <a:p>
                       <a:pPr algn="ctr"/>
                       <a:r>
-                        <a:rPr sz="2689" b="1">
+                        <a:rPr sz="2044" b="1">
                           <a:solidFill>
                             <a:srgbClr val="FFFFFF"/>
                           </a:solidFill>
@@ -5560,7 +4892,7 @@
                     <a:p>
                       <a:pPr algn="ctr"/>
                       <a:r>
-                        <a:rPr sz="2689" b="1">
+                        <a:rPr sz="2044" b="1">
                           <a:solidFill>
                             <a:srgbClr val="FFFFFF"/>
                           </a:solidFill>
@@ -5581,7 +4913,7 @@
                   </a:ext>
                 </a:extLst>
               </a:tr>
-              <a:tr h="571244">
+              <a:tr h="351535">
                 <a:tc>
                   <a:txBody>
                     <a:bodyPr/>
@@ -5589,7 +4921,7 @@
                     <a:p>
                       <a:pPr algn="l"/>
                       <a:r>
-                        <a:rPr sz="2689" b="0">
+                        <a:rPr sz="2044" b="0">
                           <a:solidFill>
                             <a:srgbClr val="1A1A1A"/>
                           </a:solidFill>
@@ -5611,7 +4943,7 @@
                     <a:p>
                       <a:pPr algn="ctr"/>
                       <a:r>
-                        <a:rPr sz="2689" b="0" dirty="0">
+                        <a:rPr sz="2044" b="0" dirty="0">
                           <a:solidFill>
                             <a:srgbClr val="1A1A1A"/>
                           </a:solidFill>
@@ -5633,7 +4965,7 @@
                     <a:p>
                       <a:pPr algn="ctr"/>
                       <a:r>
-                        <a:rPr sz="2689" b="0">
+                        <a:rPr sz="2044" b="0">
                           <a:solidFill>
                             <a:srgbClr val="1A1A1A"/>
                           </a:solidFill>
@@ -5654,7 +4986,7 @@
                   </a:ext>
                 </a:extLst>
               </a:tr>
-              <a:tr h="571244">
+              <a:tr h="351535">
                 <a:tc>
                   <a:txBody>
                     <a:bodyPr/>
@@ -5662,7 +4994,7 @@
                     <a:p>
                       <a:pPr algn="l"/>
                       <a:r>
-                        <a:rPr sz="2689" b="0">
+                        <a:rPr sz="2044" b="0">
                           <a:solidFill>
                             <a:srgbClr val="1A1A1A"/>
                           </a:solidFill>
@@ -5684,7 +5016,7 @@
                     <a:p>
                       <a:pPr algn="ctr"/>
                       <a:r>
-                        <a:rPr sz="2689" b="0" dirty="0">
+                        <a:rPr sz="2044" b="0" dirty="0">
                           <a:solidFill>
                             <a:srgbClr val="1A1A1A"/>
                           </a:solidFill>
@@ -5692,7 +5024,7 @@
                         <a:t>Qwen34B </a:t>
                       </a:r>
                       <a:r>
-                        <a:rPr sz="2689" b="0" dirty="0" err="1">
+                        <a:rPr sz="2044" b="0" dirty="0" err="1">
                           <a:solidFill>
                             <a:srgbClr val="1A1A1A"/>
                           </a:solidFill>
@@ -5700,7 +5032,7 @@
                         <a:t>zeroshot</a:t>
                       </a:r>
                       <a:r>
-                        <a:rPr sz="2689" b="0" dirty="0">
+                        <a:rPr sz="2044" b="0" dirty="0">
                           <a:solidFill>
                             <a:srgbClr val="1A1A1A"/>
                           </a:solidFill>
@@ -5722,7 +5054,7 @@
                     <a:p>
                       <a:pPr algn="ctr"/>
                       <a:r>
-                        <a:rPr sz="2689" b="0">
+                        <a:rPr sz="2044" b="0">
                           <a:solidFill>
                             <a:srgbClr val="1A1A1A"/>
                           </a:solidFill>
@@ -5743,7 +5075,7 @@
                   </a:ext>
                 </a:extLst>
               </a:tr>
-              <a:tr h="571244">
+              <a:tr h="351535">
                 <a:tc>
                   <a:txBody>
                     <a:bodyPr/>
@@ -5751,7 +5083,7 @@
                     <a:p>
                       <a:pPr algn="l"/>
                       <a:r>
-                        <a:rPr sz="2689" b="0">
+                        <a:rPr sz="2044" b="0">
                           <a:solidFill>
                             <a:srgbClr val="1A1A1A"/>
                           </a:solidFill>
@@ -5773,7 +5105,7 @@
                     <a:p>
                       <a:pPr algn="ctr"/>
                       <a:r>
-                        <a:rPr sz="2689" b="0" dirty="0">
+                        <a:rPr sz="2044" b="0" dirty="0">
                           <a:solidFill>
                             <a:srgbClr val="1A1A1A"/>
                           </a:solidFill>
@@ -5781,7 +5113,7 @@
                         <a:t>Qwen34B </a:t>
                       </a:r>
                       <a:r>
-                        <a:rPr sz="2689" b="0" dirty="0" err="1">
+                        <a:rPr sz="2044" b="0" dirty="0" err="1">
                           <a:solidFill>
                             <a:srgbClr val="1A1A1A"/>
                           </a:solidFill>
@@ -5789,7 +5121,7 @@
                         <a:t>fewshot</a:t>
                       </a:r>
                       <a:r>
-                        <a:rPr sz="2689" b="0" dirty="0">
+                        <a:rPr sz="2044" b="0" dirty="0">
                           <a:solidFill>
                             <a:srgbClr val="1A1A1A"/>
                           </a:solidFill>
@@ -5811,7 +5143,7 @@
                     <a:p>
                       <a:pPr algn="ctr"/>
                       <a:r>
-                        <a:rPr sz="2689" b="0">
+                        <a:rPr sz="2044" b="0">
                           <a:solidFill>
                             <a:srgbClr val="1A1A1A"/>
                           </a:solidFill>
@@ -5832,7 +5164,7 @@
                   </a:ext>
                 </a:extLst>
               </a:tr>
-              <a:tr h="571244">
+              <a:tr h="351535">
                 <a:tc>
                   <a:txBody>
                     <a:bodyPr/>
@@ -5840,7 +5172,7 @@
                     <a:p>
                       <a:pPr algn="l"/>
                       <a:r>
-                        <a:rPr sz="2689" b="0">
+                        <a:rPr sz="2044" b="0">
                           <a:solidFill>
                             <a:srgbClr val="1A1A1A"/>
                           </a:solidFill>
@@ -5862,7 +5194,7 @@
                     <a:p>
                       <a:pPr algn="ctr"/>
                       <a:r>
-                        <a:rPr sz="2689" b="0" dirty="0">
+                        <a:rPr sz="2044" b="0" dirty="0">
                           <a:solidFill>
                             <a:srgbClr val="1A1A1A"/>
                           </a:solidFill>
@@ -5870,7 +5202,7 @@
                         <a:t>Qwen34B structured </a:t>
                       </a:r>
                       <a:r>
-                        <a:rPr sz="2689" b="0" dirty="0" err="1">
+                        <a:rPr sz="2044" b="0" dirty="0" err="1">
                           <a:solidFill>
                             <a:srgbClr val="1A1A1A"/>
                           </a:solidFill>
@@ -5878,7 +5210,7 @@
                         <a:t>stepbystep</a:t>
                       </a:r>
                       <a:r>
-                        <a:rPr sz="2689" b="0" dirty="0">
+                        <a:rPr sz="2044" b="0" dirty="0">
                           <a:solidFill>
                             <a:srgbClr val="1A1A1A"/>
                           </a:solidFill>
@@ -5900,7 +5232,7 @@
                     <a:p>
                       <a:pPr algn="ctr"/>
                       <a:r>
-                        <a:rPr sz="2689" b="0">
+                        <a:rPr sz="2044" b="0">
                           <a:solidFill>
                             <a:srgbClr val="1A1A1A"/>
                           </a:solidFill>
@@ -5921,7 +5253,7 @@
                   </a:ext>
                 </a:extLst>
               </a:tr>
-              <a:tr h="571244">
+              <a:tr h="351535">
                 <a:tc>
                   <a:txBody>
                     <a:bodyPr/>
@@ -5929,7 +5261,7 @@
                     <a:p>
                       <a:pPr algn="l"/>
                       <a:r>
-                        <a:rPr sz="2689" b="0">
+                        <a:rPr sz="2044" b="0">
                           <a:solidFill>
                             <a:srgbClr val="1A1A1A"/>
                           </a:solidFill>
@@ -5951,7 +5283,7 @@
                     <a:p>
                       <a:pPr algn="ctr"/>
                       <a:r>
-                        <a:rPr sz="2689" b="0" dirty="0" err="1">
+                        <a:rPr sz="2044" b="0" dirty="0" err="1">
                           <a:solidFill>
                             <a:srgbClr val="1A1A1A"/>
                           </a:solidFill>
@@ -5959,7 +5291,7 @@
                         <a:t>DSPy</a:t>
                       </a:r>
                       <a:r>
-                        <a:rPr sz="2689" b="0" dirty="0">
+                        <a:rPr sz="2044" b="0" dirty="0">
                           <a:solidFill>
                             <a:srgbClr val="1A1A1A"/>
                           </a:solidFill>
@@ -5967,7 +5299,7 @@
                         <a:t> MIPROv2 </a:t>
                       </a:r>
                       <a:r>
-                        <a:rPr lang="en-IL" sz="2689" b="0" dirty="0">
+                        <a:rPr lang="en-IL" sz="2044" b="0" dirty="0">
                           <a:solidFill>
                             <a:srgbClr val="1A1A1A"/>
                           </a:solidFill>
@@ -5975,7 +5307,7 @@
                         <a:t>-</a:t>
                       </a:r>
                       <a:r>
-                        <a:rPr sz="2689" b="0" dirty="0">
+                        <a:rPr sz="2044" b="0" dirty="0">
                           <a:solidFill>
                             <a:srgbClr val="1A1A1A"/>
                           </a:solidFill>
@@ -5997,7 +5329,7 @@
                     <a:p>
                       <a:pPr algn="ctr"/>
                       <a:r>
-                        <a:rPr sz="2689" b="0">
+                        <a:rPr sz="2044" b="0">
                           <a:solidFill>
                             <a:srgbClr val="1A1A1A"/>
                           </a:solidFill>
@@ -6018,7 +5350,7 @@
                   </a:ext>
                 </a:extLst>
               </a:tr>
-              <a:tr h="571247">
+              <a:tr h="351537">
                 <a:tc>
                   <a:txBody>
                     <a:bodyPr/>
@@ -6026,7 +5358,7 @@
                     <a:p>
                       <a:pPr algn="l"/>
                       <a:r>
-                        <a:rPr sz="2689" b="1">
+                        <a:rPr sz="2044" b="1">
                           <a:solidFill>
                             <a:srgbClr val="0B2A4A"/>
                           </a:solidFill>
@@ -6048,7 +5380,7 @@
                     <a:p>
                       <a:pPr algn="ctr"/>
                       <a:r>
-                        <a:rPr sz="2689" b="1" dirty="0">
+                        <a:rPr sz="2044" b="1" dirty="0">
                           <a:solidFill>
                             <a:srgbClr val="0B2A4A"/>
                           </a:solidFill>
@@ -6056,7 +5388,7 @@
                         <a:t>Finetuned </a:t>
                       </a:r>
                       <a:r>
-                        <a:rPr sz="2689" b="1" dirty="0" err="1">
+                        <a:rPr sz="2044" b="1" dirty="0" err="1">
                           <a:solidFill>
                             <a:srgbClr val="0B2A4A"/>
                           </a:solidFill>
@@ -6064,7 +5396,7 @@
                         <a:t>microsoft</a:t>
                       </a:r>
                       <a:r>
-                        <a:rPr sz="2689" b="1" dirty="0">
+                        <a:rPr sz="2044" b="1" dirty="0">
                           <a:solidFill>
                             <a:srgbClr val="0B2A4A"/>
                           </a:solidFill>
@@ -6086,7 +5418,7 @@
                     <a:p>
                       <a:pPr algn="ctr"/>
                       <a:r>
-                        <a:rPr sz="2689" b="1">
+                        <a:rPr sz="2044" b="1">
                           <a:solidFill>
                             <a:srgbClr val="0B2A4A"/>
                           </a:solidFill>
@@ -6119,8 +5451,8 @@
         </p:nvSpPr>
         <p:spPr>
           <a:xfrm>
-            <a:off x="648000" y="25122722"/>
-            <a:ext cx="9276000" cy="420917"/>
+            <a:off x="648000" y="19974321"/>
+            <a:ext cx="9276000" cy="259026"/>
           </a:xfrm>
           <a:prstGeom prst="rect">
             <a:avLst/>
@@ -6142,7 +5474,7 @@
               </a:spcAft>
             </a:pPr>
             <a:r>
-              <a:rPr sz="3153" b="1" i="0">
+              <a:rPr sz="2397" b="1" i="0">
                 <a:solidFill>
                   <a:srgbClr val="0B2A4A"/>
                 </a:solidFill>
@@ -6161,8 +5493,8 @@
         </p:nvSpPr>
         <p:spPr>
           <a:xfrm>
-            <a:off x="648000" y="25880372"/>
-            <a:ext cx="9276000" cy="6974436"/>
+            <a:off x="648000" y="20440568"/>
+            <a:ext cx="9276000" cy="4291961"/>
           </a:xfrm>
           <a:prstGeom prst="rect">
             <a:avLst/>
@@ -6182,7 +5514,7 @@
               </a:spcAft>
             </a:pPr>
             <a:r>
-              <a:rPr sz="2503" dirty="0">
+              <a:rPr sz="1903" dirty="0">
                 <a:solidFill>
                   <a:srgbClr val="4EB39A"/>
                 </a:solidFill>
@@ -6191,7 +5523,7 @@
               <a:t>■  </a:t>
             </a:r>
             <a:r>
-              <a:rPr sz="2503" b="1" dirty="0">
+              <a:rPr sz="1903" b="1" dirty="0">
                 <a:solidFill>
                   <a:srgbClr val="1A1A1A"/>
                 </a:solidFill>
@@ -6200,7 +5532,7 @@
               <a:t>Dataset: </a:t>
             </a:r>
             <a:r>
-              <a:rPr sz="2503" dirty="0">
+              <a:rPr sz="1903" dirty="0">
                 <a:solidFill>
                   <a:srgbClr val="1A1A1A"/>
                 </a:solidFill>
@@ -6209,7 +5541,7 @@
               <a:t>Sarcasm Corpus V2 (</a:t>
             </a:r>
             <a:r>
-              <a:rPr sz="2503" dirty="0" err="1">
+              <a:rPr sz="1903" dirty="0" err="1">
                 <a:solidFill>
                   <a:srgbClr val="1A1A1A"/>
                 </a:solidFill>
@@ -6218,7 +5550,7 @@
               <a:t>Oraby</a:t>
             </a:r>
             <a:r>
-              <a:rPr sz="2503" dirty="0">
+              <a:rPr sz="1903" dirty="0">
                 <a:solidFill>
                   <a:srgbClr val="1A1A1A"/>
                 </a:solidFill>
@@ -6227,7 +5559,7 @@
               <a:t> et al., 2016) </a:t>
             </a:r>
             <a:r>
-              <a:rPr lang="en-IL" sz="2503" dirty="0">
+              <a:rPr lang="en-IL" sz="1903" dirty="0">
                 <a:solidFill>
                   <a:srgbClr val="1A1A1A"/>
                 </a:solidFill>
@@ -6236,7 +5568,7 @@
               <a:t>-</a:t>
             </a:r>
             <a:r>
-              <a:rPr sz="2503" dirty="0">
+              <a:rPr sz="1903" dirty="0">
                 <a:solidFill>
                   <a:srgbClr val="1A1A1A"/>
                 </a:solidFill>
@@ -6245,7 +5577,7 @@
               <a:t> 9,386 </a:t>
             </a:r>
             <a:r>
-              <a:rPr sz="2503" dirty="0" err="1">
+              <a:rPr sz="1903" dirty="0" err="1">
                 <a:solidFill>
                   <a:srgbClr val="1A1A1A"/>
                 </a:solidFill>
@@ -6254,7 +5586,7 @@
               <a:t>humanannotated</a:t>
             </a:r>
             <a:r>
-              <a:rPr sz="2503" dirty="0">
+              <a:rPr sz="1903" dirty="0">
                 <a:solidFill>
                   <a:srgbClr val="1A1A1A"/>
                 </a:solidFill>
@@ -6273,7 +5605,7 @@
               </a:spcAft>
             </a:pPr>
             <a:r>
-              <a:rPr sz="2503" dirty="0">
+              <a:rPr sz="1903" dirty="0">
                 <a:solidFill>
                   <a:srgbClr val="4EB39A"/>
                 </a:solidFill>
@@ -6282,7 +5614,7 @@
               <a:t>■  </a:t>
             </a:r>
             <a:r>
-              <a:rPr sz="2503" b="1" dirty="0">
+              <a:rPr sz="1903" b="1" dirty="0">
                 <a:solidFill>
                   <a:srgbClr val="1A1A1A"/>
                 </a:solidFill>
@@ -6291,7 +5623,7 @@
               <a:t>Split: </a:t>
             </a:r>
             <a:r>
-              <a:rPr sz="2503" dirty="0">
+              <a:rPr sz="1903" dirty="0">
                 <a:solidFill>
                   <a:srgbClr val="1A1A1A"/>
                 </a:solidFill>
@@ -6300,7 +5632,7 @@
               <a:t>one canonical 70/15/15 TRAIN/DEV/TEST split (seed 42) </a:t>
             </a:r>
             <a:r>
-              <a:rPr lang="en-IL" sz="2503" dirty="0">
+              <a:rPr lang="en-IL" sz="1903" dirty="0">
                 <a:solidFill>
                   <a:srgbClr val="1A1A1A"/>
                 </a:solidFill>
@@ -6309,7 +5641,7 @@
               <a:t>-</a:t>
             </a:r>
             <a:r>
-              <a:rPr sz="2503" dirty="0">
+              <a:rPr sz="1903" dirty="0">
                 <a:solidFill>
                   <a:srgbClr val="1A1A1A"/>
                 </a:solidFill>
@@ -6328,7 +5660,7 @@
               </a:spcAft>
             </a:pPr>
             <a:r>
-              <a:rPr sz="2503" dirty="0">
+              <a:rPr sz="1903" dirty="0">
                 <a:solidFill>
                   <a:srgbClr val="4EB39A"/>
                 </a:solidFill>
@@ -6337,7 +5669,7 @@
               <a:t>■  </a:t>
             </a:r>
             <a:r>
-              <a:rPr sz="2503" b="1" dirty="0">
+              <a:rPr sz="1903" b="1" dirty="0">
                 <a:solidFill>
                   <a:srgbClr val="1A1A1A"/>
                 </a:solidFill>
@@ -6346,7 +5678,7 @@
               <a:t>Sealing policy: </a:t>
             </a:r>
             <a:r>
-              <a:rPr sz="2503" dirty="0">
+              <a:rPr sz="1903" dirty="0">
                 <a:solidFill>
                   <a:srgbClr val="1A1A1A"/>
                 </a:solidFill>
@@ -6365,7 +5697,7 @@
               </a:spcAft>
             </a:pPr>
             <a:r>
-              <a:rPr sz="2503" dirty="0">
+              <a:rPr sz="1903" dirty="0">
                 <a:solidFill>
                   <a:srgbClr val="4EB39A"/>
                 </a:solidFill>
@@ -6374,7 +5706,7 @@
               <a:t>■  </a:t>
             </a:r>
             <a:r>
-              <a:rPr sz="2503" b="1" dirty="0">
+              <a:rPr sz="1903" b="1" dirty="0">
                 <a:solidFill>
                   <a:srgbClr val="1A1A1A"/>
                 </a:solidFill>
@@ -6383,7 +5715,7 @@
               <a:t>Shared evaluator: </a:t>
             </a:r>
             <a:r>
-              <a:rPr sz="2503" dirty="0">
+              <a:rPr sz="1903" dirty="0">
                 <a:solidFill>
                   <a:srgbClr val="1A1A1A"/>
                 </a:solidFill>
@@ -6392,7 +5724,7 @@
               <a:t>one implementation of Accuracy / </a:t>
             </a:r>
             <a:r>
-              <a:rPr sz="2503" dirty="0" err="1">
+              <a:rPr sz="1903" dirty="0" err="1">
                 <a:solidFill>
                   <a:srgbClr val="1A1A1A"/>
                 </a:solidFill>
@@ -6401,7 +5733,7 @@
               <a:t>perclass</a:t>
             </a:r>
             <a:r>
-              <a:rPr sz="2503" dirty="0">
+              <a:rPr sz="1903" dirty="0">
                 <a:solidFill>
                   <a:srgbClr val="1A1A1A"/>
                 </a:solidFill>
@@ -6420,7 +5752,7 @@
               </a:spcAft>
             </a:pPr>
             <a:r>
-              <a:rPr sz="2503" dirty="0">
+              <a:rPr sz="1903" dirty="0">
                 <a:solidFill>
                   <a:srgbClr val="4EB39A"/>
                 </a:solidFill>
@@ -6429,7 +5761,7 @@
               <a:t>■  </a:t>
             </a:r>
             <a:r>
-              <a:rPr sz="2503" b="1" dirty="0">
+              <a:rPr sz="1903" b="1" dirty="0">
                 <a:solidFill>
                   <a:srgbClr val="1A1A1A"/>
                 </a:solidFill>
@@ -6438,7 +5770,7 @@
               <a:t>Base LLM fixed: </a:t>
             </a:r>
             <a:r>
-              <a:rPr sz="2503" dirty="0">
+              <a:rPr sz="1903" dirty="0">
                 <a:solidFill>
                   <a:srgbClr val="1A1A1A"/>
                 </a:solidFill>
@@ -6447,7 +5779,7 @@
               <a:t>M2–M5 all run the same local Qwen34BInstruct2507, isolating prompting technique from </a:t>
             </a:r>
             <a:r>
-              <a:rPr sz="2503" dirty="0" err="1">
+              <a:rPr sz="1903" dirty="0" err="1">
                 <a:solidFill>
                   <a:srgbClr val="1A1A1A"/>
                 </a:solidFill>
@@ -6456,7 +5788,7 @@
               <a:t>basemodel</a:t>
             </a:r>
             <a:r>
-              <a:rPr sz="2503" dirty="0">
+              <a:rPr sz="1903" dirty="0">
                 <a:solidFill>
                   <a:srgbClr val="1A1A1A"/>
                 </a:solidFill>
@@ -6475,8 +5807,8 @@
         </p:nvSpPr>
         <p:spPr>
           <a:xfrm>
-            <a:off x="10500000" y="25122722"/>
-            <a:ext cx="9276000" cy="420917"/>
+            <a:off x="10500000" y="19974321"/>
+            <a:ext cx="9276000" cy="259026"/>
           </a:xfrm>
           <a:prstGeom prst="rect">
             <a:avLst/>
@@ -6498,7 +5830,7 @@
               </a:spcAft>
             </a:pPr>
             <a:r>
-              <a:rPr sz="3153" b="1" i="0">
+              <a:rPr sz="2397" b="1" i="0">
                 <a:solidFill>
                   <a:srgbClr val="0B2A4A"/>
                 </a:solidFill>
@@ -6525,8 +5857,8 @@
         </p:blipFill>
         <p:spPr>
           <a:xfrm>
-            <a:off x="10500000" y="25880372"/>
-            <a:ext cx="4530000" cy="3510778"/>
+            <a:off x="10500000" y="20440568"/>
+            <a:ext cx="4530000" cy="2160479"/>
           </a:xfrm>
           <a:prstGeom prst="rect">
             <a:avLst/>
@@ -6546,8 +5878,8 @@
         </p:nvSpPr>
         <p:spPr>
           <a:xfrm>
-            <a:off x="10500000" y="29517426"/>
-            <a:ext cx="4530000" cy="709067"/>
+            <a:off x="10500000" y="22678755"/>
+            <a:ext cx="4530000" cy="436349"/>
           </a:xfrm>
           <a:prstGeom prst="rect">
             <a:avLst/>
@@ -6569,7 +5901,7 @@
               </a:spcAft>
             </a:pPr>
             <a:r>
-              <a:rPr sz="1947" b="0" i="1" dirty="0">
+              <a:rPr sz="1480" b="0" i="1" dirty="0">
                 <a:solidFill>
                   <a:srgbClr val="555555"/>
                 </a:solidFill>
@@ -6578,7 +5910,7 @@
               <a:t>Fig. 5 </a:t>
             </a:r>
             <a:r>
-              <a:rPr lang="en-IL" sz="1947" b="0" i="1" dirty="0">
+              <a:rPr lang="en-IL" sz="1480" b="0" i="1" dirty="0">
                 <a:solidFill>
                   <a:srgbClr val="555555"/>
                 </a:solidFill>
@@ -6587,7 +5919,7 @@
               <a:t>-</a:t>
             </a:r>
             <a:r>
-              <a:rPr sz="1947" b="0" i="1" dirty="0">
+              <a:rPr sz="1480" b="0" i="1" dirty="0">
                 <a:solidFill>
                   <a:srgbClr val="555555"/>
                 </a:solidFill>
@@ -6614,8 +5946,8 @@
         </p:blipFill>
         <p:spPr>
           <a:xfrm>
-            <a:off x="15246000" y="25880372"/>
-            <a:ext cx="4530000" cy="3510778"/>
+            <a:off x="15246000" y="20440568"/>
+            <a:ext cx="4530000" cy="2160479"/>
           </a:xfrm>
           <a:prstGeom prst="rect">
             <a:avLst/>
@@ -6635,8 +5967,8 @@
         </p:nvSpPr>
         <p:spPr>
           <a:xfrm>
-            <a:off x="15246000" y="29517426"/>
-            <a:ext cx="4530000" cy="709067"/>
+            <a:off x="15246000" y="22678755"/>
+            <a:ext cx="4530000" cy="436349"/>
           </a:xfrm>
           <a:prstGeom prst="rect">
             <a:avLst/>
@@ -6658,7 +5990,7 @@
               </a:spcAft>
             </a:pPr>
             <a:r>
-              <a:rPr sz="1947" b="0" i="1" dirty="0">
+              <a:rPr sz="1480" b="0" i="1" dirty="0">
                 <a:solidFill>
                   <a:srgbClr val="555555"/>
                 </a:solidFill>
@@ -6667,7 +5999,7 @@
               <a:t>Fig. 6 </a:t>
             </a:r>
             <a:r>
-              <a:rPr lang="en-IL" sz="1947" b="0" i="1" dirty="0">
+              <a:rPr lang="en-IL" sz="1480" b="0" i="1" dirty="0">
                 <a:solidFill>
                   <a:srgbClr val="555555"/>
                 </a:solidFill>
@@ -6676,7 +6008,7 @@
               <a:t>-</a:t>
             </a:r>
             <a:r>
-              <a:rPr sz="1947" b="0" i="1" dirty="0">
+              <a:rPr sz="1480" b="0" i="1" dirty="0">
                 <a:solidFill>
                   <a:srgbClr val="555555"/>
                 </a:solidFill>
@@ -6685,7 +6017,7 @@
               <a:t> Perclass F1 </a:t>
             </a:r>
             <a:r>
-              <a:rPr lang="en-IL" sz="1947" b="0" i="1" dirty="0">
+              <a:rPr lang="en-IL" sz="1480" b="0" i="1" dirty="0">
                 <a:solidFill>
                   <a:srgbClr val="555555"/>
                 </a:solidFill>
@@ -6694,7 +6026,7 @@
               <a:t>-</a:t>
             </a:r>
             <a:r>
-              <a:rPr sz="1947" b="0" i="1" dirty="0">
+              <a:rPr sz="1480" b="0" i="1" dirty="0">
                 <a:solidFill>
                   <a:srgbClr val="555555"/>
                 </a:solidFill>
@@ -6703,7 +6035,7 @@
               <a:t> the </a:t>
             </a:r>
             <a:r>
-              <a:rPr sz="1947" b="0" i="1" dirty="0" err="1">
+              <a:rPr sz="1480" b="0" i="1" dirty="0" err="1">
                 <a:solidFill>
                   <a:srgbClr val="555555"/>
                 </a:solidFill>
@@ -6712,7 +6044,7 @@
               <a:t>sarcasticoverprediction</a:t>
             </a:r>
             <a:r>
-              <a:rPr sz="1947" b="0" i="1" dirty="0">
+              <a:rPr sz="1480" b="0" i="1" dirty="0">
                 <a:solidFill>
                   <a:srgbClr val="555555"/>
                 </a:solidFill>
@@ -6739,8 +6071,8 @@
         </p:blipFill>
         <p:spPr>
           <a:xfrm>
-            <a:off x="10500000" y="30780177"/>
-            <a:ext cx="4530000" cy="4372967"/>
+            <a:off x="10500000" y="23455832"/>
+            <a:ext cx="4530000" cy="2691057"/>
           </a:xfrm>
           <a:prstGeom prst="rect">
             <a:avLst/>
@@ -6760,8 +6092,8 @@
         </p:nvSpPr>
         <p:spPr>
           <a:xfrm>
-            <a:off x="10500000" y="35279419"/>
-            <a:ext cx="4530000" cy="709067"/>
+            <a:off x="10500000" y="26224596"/>
+            <a:ext cx="4530000" cy="436349"/>
           </a:xfrm>
           <a:prstGeom prst="rect">
             <a:avLst/>
@@ -6783,7 +6115,7 @@
               </a:spcAft>
             </a:pPr>
             <a:r>
-              <a:rPr sz="1947" b="0" i="1" dirty="0">
+              <a:rPr sz="1480" b="0" i="1" dirty="0">
                 <a:solidFill>
                   <a:srgbClr val="555555"/>
                 </a:solidFill>
@@ -6792,7 +6124,7 @@
               <a:t>Fig. 7 </a:t>
             </a:r>
             <a:r>
-              <a:rPr lang="en-IL" sz="1947" b="0" i="1" dirty="0">
+              <a:rPr lang="en-IL" sz="1480" b="0" i="1" dirty="0">
                 <a:solidFill>
                   <a:srgbClr val="555555"/>
                 </a:solidFill>
@@ -6801,7 +6133,7 @@
               <a:t>-</a:t>
             </a:r>
             <a:r>
-              <a:rPr sz="1947" b="0" i="1" dirty="0">
+              <a:rPr sz="1480" b="0" i="1" dirty="0">
                 <a:solidFill>
                   <a:srgbClr val="555555"/>
                 </a:solidFill>
@@ -6828,8 +6160,8 @@
         </p:blipFill>
         <p:spPr>
           <a:xfrm>
-            <a:off x="15246000" y="30780177"/>
-            <a:ext cx="4530000" cy="2442780"/>
+            <a:off x="15246000" y="23455832"/>
+            <a:ext cx="4530000" cy="1503249"/>
           </a:xfrm>
           <a:prstGeom prst="rect">
             <a:avLst/>
@@ -6849,8 +6181,8 @@
         </p:nvSpPr>
         <p:spPr>
           <a:xfrm>
-            <a:off x="15246000" y="33349232"/>
-            <a:ext cx="4530000" cy="709067"/>
+            <a:off x="15246000" y="25036789"/>
+            <a:ext cx="4530000" cy="436349"/>
           </a:xfrm>
           <a:prstGeom prst="rect">
             <a:avLst/>
@@ -6872,7 +6204,7 @@
               </a:spcAft>
             </a:pPr>
             <a:r>
-              <a:rPr sz="1947" b="0" i="1" dirty="0">
+              <a:rPr sz="1480" b="0" i="1" dirty="0">
                 <a:solidFill>
                   <a:srgbClr val="555555"/>
                 </a:solidFill>
@@ -6881,7 +6213,7 @@
               <a:t>Fig. 8 </a:t>
             </a:r>
             <a:r>
-              <a:rPr lang="en-IL" sz="1947" b="0" i="1" dirty="0">
+              <a:rPr lang="en-IL" sz="1480" b="0" i="1" dirty="0">
                 <a:solidFill>
                   <a:srgbClr val="555555"/>
                 </a:solidFill>
@@ -6890,7 +6222,7 @@
               <a:t>-</a:t>
             </a:r>
             <a:r>
-              <a:rPr sz="1947" b="0" i="1" dirty="0">
+              <a:rPr sz="1480" b="0" i="1" dirty="0">
                 <a:solidFill>
                   <a:srgbClr val="555555"/>
                 </a:solidFill>
@@ -6909,8 +6241,8 @@
         </p:nvSpPr>
         <p:spPr>
           <a:xfrm>
-            <a:off x="20352000" y="25122722"/>
-            <a:ext cx="9276000" cy="420917"/>
+            <a:off x="20352000" y="19974321"/>
+            <a:ext cx="9276000" cy="259026"/>
           </a:xfrm>
           <a:prstGeom prst="rect">
             <a:avLst/>
@@ -6932,7 +6264,7 @@
               </a:spcAft>
             </a:pPr>
             <a:r>
-              <a:rPr sz="3153" b="1" i="0">
+              <a:rPr sz="2397" b="1" i="0">
                 <a:solidFill>
                   <a:srgbClr val="0B2A4A"/>
                 </a:solidFill>
@@ -6951,8 +6283,8 @@
         </p:nvSpPr>
         <p:spPr>
           <a:xfrm>
-            <a:off x="20352000" y="25880372"/>
-            <a:ext cx="9276000" cy="6974436"/>
+            <a:off x="20352000" y="20440568"/>
+            <a:ext cx="9276000" cy="4291961"/>
           </a:xfrm>
           <a:prstGeom prst="rect">
             <a:avLst/>
@@ -6972,7 +6304,7 @@
               </a:spcAft>
             </a:pPr>
             <a:r>
-              <a:rPr sz="2503" dirty="0">
+              <a:rPr sz="1903" dirty="0">
                 <a:solidFill>
                   <a:srgbClr val="4EB39A"/>
                 </a:solidFill>
@@ -6981,7 +6313,7 @@
               <a:t>■  </a:t>
             </a:r>
             <a:r>
-              <a:rPr sz="2503" b="1" dirty="0">
+              <a:rPr sz="1903" b="1" dirty="0">
                 <a:solidFill>
                   <a:srgbClr val="1A1A1A"/>
                 </a:solidFill>
@@ -6990,7 +6322,7 @@
               <a:t>Winner </a:t>
             </a:r>
             <a:r>
-              <a:rPr lang="en-IL" sz="2503" b="1" dirty="0">
+              <a:rPr lang="en-IL" sz="1903" b="1" dirty="0">
                 <a:solidFill>
                   <a:srgbClr val="1A1A1A"/>
                 </a:solidFill>
@@ -6999,7 +6331,7 @@
               <a:t>-</a:t>
             </a:r>
             <a:r>
-              <a:rPr sz="2503" b="1" dirty="0">
+              <a:rPr sz="1903" b="1" dirty="0">
                 <a:solidFill>
                   <a:srgbClr val="1A1A1A"/>
                 </a:solidFill>
@@ -7008,7 +6340,7 @@
               <a:t> M6 (finetuned </a:t>
             </a:r>
             <a:r>
-              <a:rPr sz="2503" b="1" dirty="0" err="1">
+              <a:rPr sz="1903" b="1" dirty="0" err="1">
                 <a:solidFill>
                   <a:srgbClr val="1A1A1A"/>
                 </a:solidFill>
@@ -7017,7 +6349,7 @@
               <a:t>DeBERTa</a:t>
             </a:r>
             <a:r>
-              <a:rPr sz="2503" b="1" dirty="0">
+              <a:rPr sz="1903" b="1" dirty="0">
                 <a:solidFill>
                   <a:srgbClr val="1A1A1A"/>
                 </a:solidFill>
@@ -7026,7 +6358,7 @@
               <a:t>): </a:t>
             </a:r>
             <a:r>
-              <a:rPr sz="2503" dirty="0">
+              <a:rPr sz="1903" dirty="0">
                 <a:solidFill>
                   <a:srgbClr val="1A1A1A"/>
                 </a:solidFill>
@@ -7035,7 +6367,7 @@
               <a:t>0.8209 Macro F1 </a:t>
             </a:r>
             <a:r>
-              <a:rPr lang="en-IL" sz="2503" dirty="0">
+              <a:rPr lang="en-IL" sz="1903" dirty="0">
                 <a:solidFill>
                   <a:srgbClr val="1A1A1A"/>
                 </a:solidFill>
@@ -7044,7 +6376,7 @@
               <a:t>-</a:t>
             </a:r>
             <a:r>
-              <a:rPr sz="2503" dirty="0">
+              <a:rPr sz="1903" dirty="0">
                 <a:solidFill>
                   <a:srgbClr val="1A1A1A"/>
                 </a:solidFill>
@@ -7053,7 +6385,7 @@
               <a:t> 15–25 points over every </a:t>
             </a:r>
             <a:r>
-              <a:rPr sz="2503" dirty="0" err="1">
+              <a:rPr sz="1903" dirty="0" err="1">
                 <a:solidFill>
                   <a:srgbClr val="1A1A1A"/>
                 </a:solidFill>
@@ -7062,7 +6394,7 @@
               <a:t>promptedLLM</a:t>
             </a:r>
             <a:r>
-              <a:rPr sz="2503" dirty="0">
+              <a:rPr sz="1903" dirty="0">
                 <a:solidFill>
                   <a:srgbClr val="1A1A1A"/>
                 </a:solidFill>
@@ -7081,7 +6413,7 @@
               </a:spcAft>
             </a:pPr>
             <a:r>
-              <a:rPr sz="2503" dirty="0">
+              <a:rPr sz="1903" dirty="0">
                 <a:solidFill>
                   <a:srgbClr val="4EB39A"/>
                 </a:solidFill>
@@ -7090,7 +6422,7 @@
               <a:t>■  </a:t>
             </a:r>
             <a:r>
-              <a:rPr sz="2503" b="1" dirty="0">
+              <a:rPr sz="1903" b="1" dirty="0">
                 <a:solidFill>
                   <a:srgbClr val="1A1A1A"/>
                 </a:solidFill>
@@ -7099,7 +6431,7 @@
               <a:t>More prompting ≠ better: </a:t>
             </a:r>
             <a:r>
-              <a:rPr sz="2503" dirty="0">
+              <a:rPr sz="1903" dirty="0">
                 <a:solidFill>
                   <a:srgbClr val="1A1A1A"/>
                 </a:solidFill>
@@ -7108,7 +6440,7 @@
               <a:t>plain </a:t>
             </a:r>
             <a:r>
-              <a:rPr sz="2503" dirty="0" err="1">
+              <a:rPr sz="1903" dirty="0" err="1">
                 <a:solidFill>
                   <a:srgbClr val="1A1A1A"/>
                 </a:solidFill>
@@ -7117,7 +6449,7 @@
               <a:t>zeroshot</a:t>
             </a:r>
             <a:r>
-              <a:rPr sz="2503" dirty="0">
+              <a:rPr sz="1903" dirty="0">
                 <a:solidFill>
                   <a:srgbClr val="1A1A1A"/>
                 </a:solidFill>
@@ -7126,7 +6458,7 @@
               <a:t> beat both </a:t>
             </a:r>
             <a:r>
-              <a:rPr sz="2503" dirty="0" err="1">
+              <a:rPr sz="1903" dirty="0" err="1">
                 <a:solidFill>
                   <a:srgbClr val="1A1A1A"/>
                 </a:solidFill>
@@ -7135,7 +6467,7 @@
               <a:t>fewshot</a:t>
             </a:r>
             <a:r>
-              <a:rPr sz="2503" dirty="0">
+              <a:rPr sz="1903" dirty="0">
                 <a:solidFill>
                   <a:srgbClr val="1A1A1A"/>
                 </a:solidFill>
@@ -7144,7 +6476,7 @@
               <a:t> and structured reasoning; only </a:t>
             </a:r>
             <a:r>
-              <a:rPr sz="2503" dirty="0" err="1">
+              <a:rPr sz="1903" dirty="0" err="1">
                 <a:solidFill>
                   <a:srgbClr val="1A1A1A"/>
                 </a:solidFill>
@@ -7153,7 +6485,7 @@
               <a:t>DSPy's</a:t>
             </a:r>
             <a:r>
-              <a:rPr sz="2503" dirty="0">
+              <a:rPr sz="1903" dirty="0">
                 <a:solidFill>
                   <a:srgbClr val="1A1A1A"/>
                 </a:solidFill>
@@ -7172,7 +6504,7 @@
               </a:spcAft>
             </a:pPr>
             <a:r>
-              <a:rPr sz="2503" dirty="0">
+              <a:rPr sz="1903" dirty="0">
                 <a:solidFill>
                   <a:srgbClr val="4EB39A"/>
                 </a:solidFill>
@@ -7181,7 +6513,7 @@
               <a:t>■  </a:t>
             </a:r>
             <a:r>
-              <a:rPr sz="2503" b="1" dirty="0">
+              <a:rPr sz="1903" b="1" dirty="0">
                 <a:solidFill>
                   <a:srgbClr val="1A1A1A"/>
                 </a:solidFill>
@@ -7190,7 +6522,7 @@
               <a:t>Universal LLM bias: </a:t>
             </a:r>
             <a:r>
-              <a:rPr sz="2503" dirty="0">
+              <a:rPr sz="1903" dirty="0">
                 <a:solidFill>
                   <a:srgbClr val="1A1A1A"/>
                 </a:solidFill>
@@ -7199,7 +6531,7 @@
               <a:t>every prompted method overpredicts “sarcastic” </a:t>
             </a:r>
             <a:r>
-              <a:rPr lang="en-IL" sz="2503" dirty="0">
+              <a:rPr lang="en-IL" sz="1903" dirty="0">
                 <a:solidFill>
                   <a:srgbClr val="1A1A1A"/>
                 </a:solidFill>
@@ -7208,7 +6540,7 @@
               <a:t>-</a:t>
             </a:r>
             <a:r>
-              <a:rPr sz="2503" dirty="0">
+              <a:rPr sz="1903" dirty="0">
                 <a:solidFill>
                   <a:srgbClr val="1A1A1A"/>
                 </a:solidFill>
@@ -7217,7 +6549,7 @@
               <a:t> 94–97% sarcastic recall vs. only 28–44% </a:t>
             </a:r>
             <a:r>
-              <a:rPr sz="2503" dirty="0" err="1">
+              <a:rPr sz="1903" dirty="0" err="1">
                 <a:solidFill>
                   <a:srgbClr val="1A1A1A"/>
                 </a:solidFill>
@@ -7226,7 +6558,7 @@
               <a:t>notsarcastic</a:t>
             </a:r>
             <a:r>
-              <a:rPr sz="2503" dirty="0">
+              <a:rPr sz="1903" dirty="0">
                 <a:solidFill>
                   <a:srgbClr val="1A1A1A"/>
                 </a:solidFill>
@@ -7245,7 +6577,7 @@
               </a:spcAft>
             </a:pPr>
             <a:r>
-              <a:rPr sz="2503" dirty="0">
+              <a:rPr sz="1903" dirty="0">
                 <a:solidFill>
                   <a:srgbClr val="4EB39A"/>
                 </a:solidFill>
@@ -7254,7 +6586,7 @@
               <a:t>■  </a:t>
             </a:r>
             <a:r>
-              <a:rPr sz="2503" b="1" dirty="0">
+              <a:rPr sz="1903" b="1" dirty="0">
                 <a:solidFill>
                   <a:srgbClr val="1A1A1A"/>
                 </a:solidFill>
@@ -7263,7 +6595,7 @@
               <a:t>Two clear families: </a:t>
             </a:r>
             <a:r>
-              <a:rPr sz="2503" dirty="0">
+              <a:rPr sz="1903" dirty="0">
                 <a:solidFill>
                   <a:srgbClr val="1A1A1A"/>
                 </a:solidFill>
@@ -7272,7 +6604,7 @@
               <a:t>the 4 LLM methods agree with each other 88–95% of the time; M1+M6 (trained methods) agree with each other 81% </a:t>
             </a:r>
             <a:r>
-              <a:rPr lang="en-IL" sz="2503" dirty="0">
+              <a:rPr lang="en-IL" sz="1903" dirty="0">
                 <a:solidFill>
                   <a:srgbClr val="1A1A1A"/>
                 </a:solidFill>
@@ -7281,7 +6613,7 @@
               <a:t>-</a:t>
             </a:r>
             <a:r>
-              <a:rPr sz="2503" dirty="0">
+              <a:rPr sz="1903" dirty="0">
                 <a:solidFill>
                   <a:srgbClr val="1A1A1A"/>
                 </a:solidFill>
@@ -7300,7 +6632,7 @@
               </a:spcAft>
             </a:pPr>
             <a:r>
-              <a:rPr sz="2503" dirty="0">
+              <a:rPr sz="1903" dirty="0">
                 <a:solidFill>
                   <a:srgbClr val="4EB39A"/>
                 </a:solidFill>
@@ -7309,7 +6641,7 @@
               <a:t>■  </a:t>
             </a:r>
             <a:r>
-              <a:rPr sz="2503" b="1" dirty="0">
+              <a:rPr sz="1903" b="1" dirty="0">
                 <a:solidFill>
                   <a:srgbClr val="1A1A1A"/>
                 </a:solidFill>
@@ -7318,7 +6650,7 @@
               <a:t>Hardest cases: </a:t>
             </a:r>
             <a:r>
-              <a:rPr sz="2503" dirty="0">
+              <a:rPr sz="1903" dirty="0">
                 <a:solidFill>
                   <a:srgbClr val="1A1A1A"/>
                 </a:solidFill>
@@ -7337,8 +6669,8 @@
         </p:nvSpPr>
         <p:spPr>
           <a:xfrm>
-            <a:off x="20352000" y="33359909"/>
-            <a:ext cx="9276000" cy="420917"/>
+            <a:off x="20352000" y="25043360"/>
+            <a:ext cx="9276000" cy="259026"/>
           </a:xfrm>
           <a:prstGeom prst="rect">
             <a:avLst/>
@@ -7360,7 +6692,7 @@
               </a:spcAft>
             </a:pPr>
             <a:r>
-              <a:rPr sz="3153" b="1" i="0">
+              <a:rPr sz="2397" b="1" i="0">
                 <a:solidFill>
                   <a:srgbClr val="0B2A4A"/>
                 </a:solidFill>
@@ -7379,8 +6711,8 @@
         </p:nvSpPr>
         <p:spPr>
           <a:xfrm>
-            <a:off x="20352000" y="34117559"/>
-            <a:ext cx="9276000" cy="1519344"/>
+            <a:off x="20352000" y="25509606"/>
+            <a:ext cx="9276000" cy="934981"/>
           </a:xfrm>
           <a:prstGeom prst="rect">
             <a:avLst/>
@@ -7402,7 +6734,7 @@
               </a:spcAft>
             </a:pPr>
             <a:r>
-              <a:rPr sz="2503" b="0" i="0" dirty="0">
+              <a:rPr sz="1903" b="0" i="0" dirty="0">
                 <a:solidFill>
                   <a:srgbClr val="1A1A1A"/>
                 </a:solidFill>
@@ -7411,7 +6743,7 @@
               <a:t>M6 for production </a:t>
             </a:r>
             <a:r>
-              <a:rPr lang="en-IL" sz="2503" b="0" i="0" dirty="0">
+              <a:rPr lang="en-IL" sz="1903" b="0" i="0" dirty="0">
                 <a:solidFill>
                   <a:srgbClr val="1A1A1A"/>
                 </a:solidFill>
@@ -7420,7 +6752,7 @@
               <a:t>-</a:t>
             </a:r>
             <a:r>
-              <a:rPr sz="2503" b="0" i="0" dirty="0">
+              <a:rPr sz="1903" b="0" i="0" dirty="0">
                 <a:solidFill>
                   <a:srgbClr val="1A1A1A"/>
                 </a:solidFill>
@@ -7429,7 +6761,7 @@
               <a:t> best accuracy, most balanced predictor, and dramatically cheaper/faster than any prompted LLM. M1 (TFIDF + LR) as a </a:t>
             </a:r>
             <a:r>
-              <a:rPr sz="2503" b="0" i="0" dirty="0" err="1">
+              <a:rPr sz="1903" b="0" i="0" dirty="0" err="1">
                 <a:solidFill>
                   <a:srgbClr val="1A1A1A"/>
                 </a:solidFill>
@@ -7438,7 +6770,7 @@
               <a:t>CPUonly</a:t>
             </a:r>
             <a:r>
-              <a:rPr sz="2503" b="0" i="0" dirty="0">
+              <a:rPr sz="1903" b="0" i="0" dirty="0">
                 <a:solidFill>
                   <a:srgbClr val="1A1A1A"/>
                 </a:solidFill>
@@ -7838,6 +7170,703 @@
                 <a:latin typeface="Calibri"/>
               </a:rPr>
               <a:t> Pipelines. ICLR 2024.   [6] Qwen Team, Alibaba Cloud (2025). Qwen3 Technical Report.</a:t>
+            </a:r>
+          </a:p>
+        </p:txBody>
+      </p:sp>
+      <p:sp>
+        <p:nvSpPr>
+          <p:cNvPr id="54" name="Rectangle 53"/>
+          <p:cNvSpPr/>
+          <p:nvPr/>
+        </p:nvSpPr>
+        <p:spPr>
+          <a:xfrm>
+            <a:off x="0" y="27422362"/>
+            <a:ext cx="30276000" cy="500000"/>
+          </a:xfrm>
+          <a:prstGeom prst="rect">
+            <a:avLst/>
+          </a:prstGeom>
+          <a:solidFill>
+            <a:srgbClr val="0B2A4A"/>
+          </a:solidFill>
+          <a:ln>
+            <a:noFill/>
+          </a:ln>
+        </p:spPr>
+        <p:style>
+          <a:lnRef idx="1">
+            <a:schemeClr val="accent1"/>
+          </a:lnRef>
+          <a:fillRef idx="3">
+            <a:schemeClr val="accent1"/>
+          </a:fillRef>
+          <a:effectRef idx="2">
+            <a:schemeClr val="accent1"/>
+          </a:effectRef>
+          <a:fontRef idx="minor">
+            <a:schemeClr val="lt1"/>
+          </a:fontRef>
+        </p:style>
+        <p:txBody>
+          <a:bodyPr rtlCol="0" anchor="ctr"/>
+          <a:lstStyle/>
+          <a:p>
+            <a:pPr algn="ctr"/>
+          </a:p>
+        </p:txBody>
+      </p:sp>
+      <p:sp>
+        <p:nvSpPr>
+          <p:cNvPr id="55" name="TextBox 54"/>
+          <p:cNvSpPr txBox="1"/>
+          <p:nvPr/>
+        </p:nvSpPr>
+        <p:spPr>
+          <a:xfrm>
+            <a:off x="648000" y="27500362"/>
+            <a:ext cx="28980000" cy="422000"/>
+          </a:xfrm>
+          <a:prstGeom prst="rect">
+            <a:avLst/>
+          </a:prstGeom>
+          <a:noFill/>
+        </p:spPr>
+        <p:txBody>
+          <a:bodyPr wrap="square">
+            <a:spAutoFit/>
+          </a:bodyPr>
+          <a:lstStyle/>
+          <a:p>
+            <a:r>
+              <a:rPr sz="2397" b="1">
+                <a:solidFill>
+                  <a:srgbClr val="FFFFFF"/>
+                </a:solidFill>
+                <a:latin typeface="Calibri"/>
+              </a:rPr>
+              <a:t>PART III - SIGN GENERALIZATION</a:t>
+            </a:r>
+          </a:p>
+        </p:txBody>
+      </p:sp>
+      <p:sp>
+        <p:nvSpPr>
+          <p:cNvPr id="56" name="TextBox 55"/>
+          <p:cNvSpPr txBox="1"/>
+          <p:nvPr/>
+        </p:nvSpPr>
+        <p:spPr>
+          <a:xfrm>
+            <a:off x="648000" y="28010362"/>
+            <a:ext cx="9276000" cy="230000"/>
+          </a:xfrm>
+          <a:prstGeom prst="rect">
+            <a:avLst/>
+          </a:prstGeom>
+          <a:noFill/>
+        </p:spPr>
+        <p:txBody>
+          <a:bodyPr wrap="square">
+            <a:spAutoFit/>
+          </a:bodyPr>
+          <a:lstStyle/>
+          <a:p>
+            <a:r>
+              <a:rPr sz="2397" b="1">
+                <a:solidFill>
+                  <a:srgbClr val="0B2A4A"/>
+                </a:solidFill>
+                <a:latin typeface="Calibri"/>
+              </a:rPr>
+              <a:t>Setup &amp; Method</a:t>
+            </a:r>
+          </a:p>
+        </p:txBody>
+      </p:sp>
+      <p:sp>
+        <p:nvSpPr>
+          <p:cNvPr id="57" name="TextBox 56"/>
+          <p:cNvSpPr txBox="1"/>
+          <p:nvPr/>
+        </p:nvSpPr>
+        <p:spPr>
+          <a:xfrm>
+            <a:off x="10500000" y="28010362"/>
+            <a:ext cx="9276000" cy="230000"/>
+          </a:xfrm>
+          <a:prstGeom prst="rect">
+            <a:avLst/>
+          </a:prstGeom>
+          <a:noFill/>
+        </p:spPr>
+        <p:txBody>
+          <a:bodyPr wrap="square">
+            <a:spAutoFit/>
+          </a:bodyPr>
+          <a:lstStyle/>
+          <a:p>
+            <a:r>
+              <a:rPr sz="2397" b="1">
+                <a:solidFill>
+                  <a:srgbClr val="0B2A4A"/>
+                </a:solidFill>
+                <a:latin typeface="Calibri"/>
+              </a:rPr>
+              <a:t>Evidence</a:t>
+            </a:r>
+          </a:p>
+        </p:txBody>
+      </p:sp>
+      <p:sp>
+        <p:nvSpPr>
+          <p:cNvPr id="58" name="TextBox 57"/>
+          <p:cNvSpPr txBox="1"/>
+          <p:nvPr/>
+        </p:nvSpPr>
+        <p:spPr>
+          <a:xfrm>
+            <a:off x="20352000" y="28010362"/>
+            <a:ext cx="9276000" cy="230000"/>
+          </a:xfrm>
+          <a:prstGeom prst="rect">
+            <a:avLst/>
+          </a:prstGeom>
+          <a:noFill/>
+        </p:spPr>
+        <p:txBody>
+          <a:bodyPr wrap="square">
+            <a:spAutoFit/>
+          </a:bodyPr>
+          <a:lstStyle/>
+          <a:p>
+            <a:r>
+              <a:rPr sz="2397" b="1">
+                <a:solidFill>
+                  <a:srgbClr val="0B2A4A"/>
+                </a:solidFill>
+                <a:latin typeface="Calibri"/>
+              </a:rPr>
+              <a:t>Key Results &amp; Conclusion</a:t>
+            </a:r>
+          </a:p>
+        </p:txBody>
+      </p:sp>
+      <p:sp>
+        <p:nvSpPr>
+          <p:cNvPr id="59" name="TextBox 58"/>
+          <p:cNvSpPr txBox="1"/>
+          <p:nvPr/>
+        </p:nvSpPr>
+        <p:spPr>
+          <a:xfrm>
+            <a:off x="648000" y="28328362"/>
+            <a:ext cx="9276000" cy="8747426"/>
+          </a:xfrm>
+          <a:prstGeom prst="rect">
+            <a:avLst/>
+          </a:prstGeom>
+          <a:noFill/>
+        </p:spPr>
+        <p:txBody>
+          <a:bodyPr wrap="square">
+            <a:spAutoFit/>
+          </a:bodyPr>
+          <a:lstStyle/>
+          <a:p>
+            <a:pPr algn="l">
+              <a:spcAft>
+                <a:spcPts val="600"/>
+              </a:spcAft>
+            </a:pPr>
+            <a:r>
+              <a:rPr sz="1903">
+                <a:solidFill>
+                  <a:srgbClr val="4EB39A"/>
+                </a:solidFill>
+                <a:latin typeface="Calibri"/>
+              </a:rPr>
+              <a:t>■  </a:t>
+            </a:r>
+            <a:r>
+              <a:rPr sz="1903" b="1">
+                <a:solidFill>
+                  <a:srgbClr val="1A1A1A"/>
+                </a:solidFill>
+                <a:latin typeface="Calibri"/>
+              </a:rPr>
+              <a:t>Question: </a:t>
+            </a:r>
+            <a:r>
+              <a:rPr sz="1903">
+                <a:solidFill>
+                  <a:srgbClr val="1A1A1A"/>
+                </a:solidFill>
+                <a:latin typeface="Calibri"/>
+              </a:rPr>
+              <a:t>do Part II's six frozen classifiers generalize to SIGN (tweets + up to 5 human sincere interpretations each)? Task A = detect the sarcastic original; Task B = tell it apart from its own interpretation.</a:t>
+            </a:r>
+          </a:p>
+          <a:p>
+            <a:pPr algn="l">
+              <a:spcAft>
+                <a:spcPts val="600"/>
+              </a:spcAft>
+            </a:pPr>
+            <a:r>
+              <a:rPr sz="1903">
+                <a:solidFill>
+                  <a:srgbClr val="4EB39A"/>
+                </a:solidFill>
+                <a:latin typeface="Calibri"/>
+              </a:rPr>
+              <a:t>■  </a:t>
+            </a:r>
+            <a:r>
+              <a:rPr sz="1903" b="1">
+                <a:solidFill>
+                  <a:srgbClr val="1A1A1A"/>
+                </a:solidFill>
+                <a:latin typeface="Calibri"/>
+              </a:rPr>
+              <a:t>Recipe: </a:t>
+            </a:r>
+            <a:r>
+              <a:rPr sz="1903">
+                <a:solidFill>
+                  <a:srgbClr val="1A1A1A"/>
+                </a:solidFill>
+                <a:latin typeface="Calibri"/>
+              </a:rPr>
+              <a:t>zero-transfer first, then combine Dataset A TRAIN + SIGN Train (beats SIGN-only, avoids forgetting Dataset A) - swept across % of SIGN Train used and k interpretations per family.</a:t>
+            </a:r>
+          </a:p>
+          <a:p>
+            <a:pPr algn="l">
+              <a:spcAft>
+                <a:spcPts val="600"/>
+              </a:spcAft>
+            </a:pPr>
+            <a:r>
+              <a:rPr sz="1903">
+                <a:solidFill>
+                  <a:srgbClr val="4EB39A"/>
+                </a:solidFill>
+                <a:latin typeface="Calibri"/>
+              </a:rPr>
+              <a:t>■  </a:t>
+            </a:r>
+            <a:r>
+              <a:rPr sz="1903" b="1">
+                <a:solidFill>
+                  <a:srgbClr val="1A1A1A"/>
+                </a:solidFill>
+                <a:latin typeface="Calibri"/>
+              </a:rPr>
+              <a:t>Rigor: </a:t>
+            </a:r>
+            <a:r>
+              <a:rPr sz="1903">
+                <a:solidFill>
+                  <a:srgbClr val="1A1A1A"/>
+                </a:solidFill>
+                <a:latin typeface="Calibri"/>
+              </a:rPr>
+              <a:t>family-safe splits (no tweet-family ever leaks across train/eval); a manual row-by-row review of predictions found ~28% of "sincere" interpretations are exact duplicates of their own sarcastic original - a real data-quality ceiling, disclosed not filtered.</a:t>
+            </a:r>
+          </a:p>
+          <a:p>
+            <a:pPr>
+              <a:spcAft>
+                <a:spcPts val="600"/>
+              </a:spcAft>
+            </a:pPr>
+            <a:r>
+              <a:rPr sz="1903">
+                <a:solidFill>
+                  <a:srgbClr val="4EB39A"/>
+                </a:solidFill>
+                <a:latin typeface="Calibri"/>
+              </a:rPr>
+              <a:t>■  </a:t>
+            </a:r>
+            <a:r>
+              <a:rPr sz="1903" b="1">
+                <a:solidFill>
+                  <a:srgbClr val="1A1A1A"/>
+                </a:solidFill>
+                <a:latin typeface="Calibri"/>
+              </a:rPr>
+              <a:t>Domain shift confirmed: </a:t>
+            </a:r>
+            <a:r>
+              <a:rPr sz="1903">
+                <a:solidFill>
+                  <a:srgbClr val="1A1A1A"/>
+                </a:solidFill>
+                <a:latin typeface="Calibri"/>
+              </a:rPr>
+              <a:t>SIGN tweets average 13.9 words vs. Dataset A's 48.7; punctuation/casing almost entirely stripped -- forum debate vs. tweet-length text, a real genre gap (Phase 2).</a:t>
+            </a:r>
+          </a:p>
+          <a:p>
+            <a:pPr>
+              <a:spcAft>
+                <a:spcPts val="600"/>
+              </a:spcAft>
+            </a:pPr>
+            <a:r>
+              <a:rPr sz="1903">
+                <a:solidFill>
+                  <a:srgbClr val="4EB39A"/>
+                </a:solidFill>
+                <a:latin typeface="Calibri"/>
+              </a:rPr>
+              <a:t>■  </a:t>
+            </a:r>
+            <a:r>
+              <a:rPr sz="1903" b="1">
+                <a:solidFill>
+                  <a:srgbClr val="1A1A1A"/>
+                </a:solidFill>
+                <a:latin typeface="Calibri"/>
+              </a:rPr>
+              <a:t>Family-aware views: </a:t>
+            </a:r>
+            <a:r>
+              <a:rPr sz="1903">
+                <a:solidFill>
+                  <a:srgbClr val="1A1A1A"/>
+                </a:solidFill>
+                <a:latin typeface="Calibri"/>
+              </a:rPr>
+              <a:t>beyond the two tasks, a Primary-Reference view (original vs. the single best interpretation) and a Full-Family view (original + all 5) test whether easier sub-cases hide behind the headline numbers.</a:t>
+            </a:r>
+          </a:p>
+        </p:txBody>
+      </p:sp>
+      <p:pic>
+        <p:nvPicPr>
+          <p:cNvPr id="60" name="Picture 59" descr="learning_curve.png"/>
+          <p:cNvPicPr>
+            <a:picLocks noChangeAspect="1"/>
+          </p:cNvPicPr>
+          <p:nvPr/>
+        </p:nvPicPr>
+        <p:blipFill>
+          <a:blip r:embed="rId10"/>
+          <a:stretch>
+            <a:fillRect/>
+          </a:stretch>
+        </p:blipFill>
+        <p:spPr>
+          <a:xfrm>
+            <a:off x="10558000" y="28328362"/>
+            <a:ext cx="9160000" cy="4148713"/>
+          </a:xfrm>
+          <a:prstGeom prst="rect">
+            <a:avLst/>
+          </a:prstGeom>
+        </p:spPr>
+      </p:pic>
+      <p:sp>
+        <p:nvSpPr>
+          <p:cNvPr id="61" name="TextBox 60"/>
+          <p:cNvSpPr txBox="1"/>
+          <p:nvPr/>
+        </p:nvSpPr>
+        <p:spPr>
+          <a:xfrm>
+            <a:off x="10500000" y="32497075"/>
+            <a:ext cx="9276000" cy="180000"/>
+          </a:xfrm>
+          <a:prstGeom prst="rect">
+            <a:avLst/>
+          </a:prstGeom>
+          <a:noFill/>
+        </p:spPr>
+        <p:txBody>
+          <a:bodyPr wrap="square">
+            <a:spAutoFit/>
+          </a:bodyPr>
+          <a:lstStyle/>
+          <a:p>
+            <a:r>
+              <a:rPr sz="1480">
+                <a:solidFill>
+                  <a:srgbClr val="1A1A1A"/>
+                </a:solidFill>
+                <a:latin typeface="Calibri"/>
+              </a:rPr>
+              <a:t>Fig. 9 - Learning curve: Macro F1 &amp; detection rate vs. % SIGN Train used (M1 vs. M6)</a:t>
+            </a:r>
+          </a:p>
+        </p:txBody>
+      </p:sp>
+      <p:pic>
+        <p:nvPicPr>
+          <p:cNvPr id="62" name="Picture 61" descr="ablation_chart.png"/>
+          <p:cNvPicPr>
+            <a:picLocks noChangeAspect="1"/>
+          </p:cNvPicPr>
+          <p:nvPr/>
+        </p:nvPicPr>
+        <p:blipFill>
+          <a:blip r:embed="rId11"/>
+          <a:stretch>
+            <a:fillRect/>
+          </a:stretch>
+        </p:blipFill>
+        <p:spPr>
+          <a:xfrm>
+            <a:off x="10558000" y="32747075"/>
+            <a:ext cx="9160000" cy="4148713"/>
+          </a:xfrm>
+          <a:prstGeom prst="rect">
+            <a:avLst/>
+          </a:prstGeom>
+        </p:spPr>
+      </p:pic>
+      <p:sp>
+        <p:nvSpPr>
+          <p:cNvPr id="63" name="TextBox 62"/>
+          <p:cNvSpPr txBox="1"/>
+          <p:nvPr/>
+        </p:nvSpPr>
+        <p:spPr>
+          <a:xfrm>
+            <a:off x="10500000" y="36915788"/>
+            <a:ext cx="9276000" cy="180000"/>
+          </a:xfrm>
+          <a:prstGeom prst="rect">
+            <a:avLst/>
+          </a:prstGeom>
+          <a:noFill/>
+        </p:spPr>
+        <p:txBody>
+          <a:bodyPr wrap="square">
+            <a:spAutoFit/>
+          </a:bodyPr>
+          <a:lstStyle/>
+          <a:p>
+            <a:r>
+              <a:rPr sz="1480">
+                <a:solidFill>
+                  <a:srgbClr val="1A1A1A"/>
+                </a:solidFill>
+                <a:latin typeface="Calibri"/>
+              </a:rPr>
+              <a:t>Fig. 10 - Interpretation-count ablation: Macro F1 &amp; detection rate vs. k (M1 vs. M6)</a:t>
+            </a:r>
+          </a:p>
+        </p:txBody>
+      </p:sp>
+      <p:sp>
+        <p:nvSpPr>
+          <p:cNvPr id="64" name="TextBox 63"/>
+          <p:cNvSpPr txBox="1"/>
+          <p:nvPr/>
+        </p:nvSpPr>
+        <p:spPr>
+          <a:xfrm>
+            <a:off x="20352000" y="28328362"/>
+            <a:ext cx="9276000" cy="8747426"/>
+          </a:xfrm>
+          <a:prstGeom prst="rect">
+            <a:avLst/>
+          </a:prstGeom>
+          <a:noFill/>
+        </p:spPr>
+        <p:txBody>
+          <a:bodyPr wrap="square">
+            <a:spAutoFit/>
+          </a:bodyPr>
+          <a:lstStyle/>
+          <a:p>
+            <a:pPr algn="l">
+              <a:spcAft>
+                <a:spcPts val="600"/>
+              </a:spcAft>
+            </a:pPr>
+            <a:r>
+              <a:rPr sz="1903">
+                <a:solidFill>
+                  <a:srgbClr val="4EB39A"/>
+                </a:solidFill>
+                <a:latin typeface="Calibri"/>
+              </a:rPr>
+              <a:t>■  </a:t>
+            </a:r>
+            <a:r>
+              <a:rPr sz="1903" b="1">
+                <a:solidFill>
+                  <a:srgbClr val="1A1A1A"/>
+                </a:solidFill>
+                <a:latin typeface="Calibri"/>
+              </a:rPr>
+              <a:t>Zero-transfer: </a:t>
+            </a:r>
+            <a:r>
+              <a:rPr sz="1903">
+                <a:solidFill>
+                  <a:srgbClr val="1A1A1A"/>
+                </a:solidFill>
+                <a:latin typeface="Calibri"/>
+              </a:rPr>
+              <a:t>collapses on Task B (M6: 0.82 -&gt; 0.47 Macro F1) but still detects most originals (M1 79.6%, M6 63.8%) - the failure is discrimination, not detection.</a:t>
+            </a:r>
+          </a:p>
+          <a:p>
+            <a:pPr algn="l">
+              <a:spcAft>
+                <a:spcPts val="600"/>
+              </a:spcAft>
+            </a:pPr>
+            <a:r>
+              <a:rPr sz="1903">
+                <a:solidFill>
+                  <a:srgbClr val="4EB39A"/>
+                </a:solidFill>
+                <a:latin typeface="Calibri"/>
+              </a:rPr>
+              <a:t>■  </a:t>
+            </a:r>
+            <a:r>
+              <a:rPr sz="1903" b="1">
+                <a:solidFill>
+                  <a:srgbClr val="1A1A1A"/>
+                </a:solidFill>
+                <a:latin typeface="Calibri"/>
+              </a:rPr>
+              <a:t>Domain adaptation: </a:t>
+            </a:r>
+            <a:r>
+              <a:rPr sz="1903">
+                <a:solidFill>
+                  <a:srgbClr val="1A1A1A"/>
+                </a:solidFill>
+                <a:latin typeface="Calibri"/>
+              </a:rPr>
+              <a:t>combining SIGN Train with Dataset A (not replacing it) closes most of the SIGN gap while Dataset A stays intact - M6 0.82 -&gt; 0.82 exactly, M1 0.74 -&gt; 0.75.</a:t>
+            </a:r>
+          </a:p>
+          <a:p>
+            <a:pPr algn="l">
+              <a:spcAft>
+                <a:spcPts val="600"/>
+              </a:spcAft>
+            </a:pPr>
+            <a:r>
+              <a:rPr sz="1903">
+                <a:solidFill>
+                  <a:srgbClr val="4EB39A"/>
+                </a:solidFill>
+                <a:latin typeface="Calibri"/>
+              </a:rPr>
+              <a:t>■  </a:t>
+            </a:r>
+            <a:r>
+              <a:rPr sz="1903" b="1">
+                <a:solidFill>
+                  <a:srgbClr val="1A1A1A"/>
+                </a:solidFill>
+                <a:latin typeface="Calibri"/>
+              </a:rPr>
+              <a:t>Sharpest finding: </a:t>
+            </a:r>
+            <a:r>
+              <a:rPr sz="1903">
+                <a:solidFill>
+                  <a:srgbClr val="1A1A1A"/>
+                </a:solidFill>
+                <a:latin typeface="Calibri"/>
+              </a:rPr>
+              <a:t>more SIGN data or interpretations improve M6 on both Task A and Task B; the same signal forces M1 to trade Task A for Task B (74.7% -&gt; 55.9% detection as k grows) - a real model-capacity contrast, repeated across 3 independent experiments.</a:t>
+            </a:r>
+          </a:p>
+          <a:p>
+            <a:pPr>
+              <a:spcAft>
+                <a:spcPts val="600"/>
+              </a:spcAft>
+            </a:pPr>
+            <a:r>
+              <a:rPr sz="1903">
+                <a:solidFill>
+                  <a:srgbClr val="4EB39A"/>
+                </a:solidFill>
+                <a:latin typeface="Calibri"/>
+              </a:rPr>
+              <a:t>■  </a:t>
+            </a:r>
+            <a:r>
+              <a:rPr sz="1903" b="1">
+                <a:solidFill>
+                  <a:srgbClr val="1A1A1A"/>
+                </a:solidFill>
+                <a:latin typeface="Calibri"/>
+              </a:rPr>
+              <a:t>Family evaluation: </a:t>
+            </a:r>
+            <a:r>
+              <a:rPr sz="1903">
+                <a:solidFill>
+                  <a:srgbClr val="1A1A1A"/>
+                </a:solidFill>
+                <a:latin typeface="Calibri"/>
+              </a:rPr>
+              <a:t>getting an entire family right (original + all 5 interpretations) is near-unsolved for every method (0-3.8%) -- one interpretation right per family is plausible, all five is not.</a:t>
+            </a:r>
+          </a:p>
+          <a:p>
+            <a:pPr>
+              <a:spcAft>
+                <a:spcPts val="600"/>
+              </a:spcAft>
+            </a:pPr>
+            <a:r>
+              <a:rPr sz="1903">
+                <a:solidFill>
+                  <a:srgbClr val="4EB39A"/>
+                </a:solidFill>
+                <a:latin typeface="Calibri"/>
+              </a:rPr>
+              <a:t>■  </a:t>
+            </a:r>
+            <a:r>
+              <a:rPr sz="1903" b="1">
+                <a:solidFill>
+                  <a:srgbClr val="1A1A1A"/>
+                </a:solidFill>
+                <a:latin typeface="Calibri"/>
+              </a:rPr>
+              <a:t>Cross-phase link: </a:t>
+            </a:r>
+            <a:r>
+              <a:rPr sz="1903">
+                <a:solidFill>
+                  <a:srgbClr val="1A1A1A"/>
+                </a:solidFill>
+                <a:latin typeface="Calibri"/>
+              </a:rPr>
+              <a:t>zero-shot Qwen3-4B detects 93.6% of SIGN originals (Task A) -- far above its own weaker Dataset A score -- pointing to a calibration limitation in prompted classification, not an inability to recognize sarcasm.</a:t>
+            </a:r>
+          </a:p>
+          <a:p>
+            <a:pPr>
+              <a:spcBef>
+                <a:spcPts val="1000"/>
+              </a:spcBef>
+            </a:pPr>
+            <a:r>
+              <a:rPr sz="1903" i="1">
+                <a:solidFill>
+                  <a:srgbClr val="0B2A4A"/>
+                </a:solidFill>
+                <a:latin typeface="Calibri"/>
+              </a:rPr>
+              <a:t>Conclusion: sarcasm detection transfers reasonably out-of-domain; the real gap is contrastive discrimination, closed by combining (not replacing) training data - at a real cost for a capacity-limited model, near-zero cost for a fine-tuned one.</a:t>
             </a:r>
           </a:p>
         </p:txBody>

</xml_diff>

<commit_message>
Add 5 more figures across the poster (Part I/II/III)
Part I: Fig.4 (word count, source vs. interpretation by model) restored
as a 3rd evidence figure.
Part II: Fig.9 (confusion matrices, M1 vs. M6) added as a 5th figure,
existing 2x2 grid compacted to make room.
Part III: rebuilt Evidence column from 2 to 4 figures -- added a new
domain-adaptation bar chart (SIGN Test vs. Dataset A TEST, conditions
A/B/C, both models) and the Phase-2 word-length distribution chart
(Dataset A vs. SIGN, the dataset "variance" finding).

Geometry re-verified: all three parts' content stays within their
allotted bounds with a positive margin before the next section.
</commit_message>
<xml_diff>
--- a/Sarcasm_Project_Poster.pptx
+++ b/Sarcasm_Project_Poster.pptx
@@ -5858,7 +5858,7 @@
         <p:spPr>
           <a:xfrm>
             <a:off x="10500000" y="20440568"/>
-            <a:ext cx="4530000" cy="2160479"/>
+            <a:ext cx="4530000" cy="1620359"/>
           </a:xfrm>
           <a:prstGeom prst="rect">
             <a:avLst/>
@@ -5878,8 +5878,8 @@
         </p:nvSpPr>
         <p:spPr>
           <a:xfrm>
-            <a:off x="10500000" y="22678755"/>
-            <a:ext cx="4530000" cy="436349"/>
+            <a:off x="10500000" y="22119208"/>
+            <a:ext cx="4530000" cy="327262"/>
           </a:xfrm>
           <a:prstGeom prst="rect">
             <a:avLst/>
@@ -5947,7 +5947,7 @@
         <p:spPr>
           <a:xfrm>
             <a:off x="15246000" y="20440568"/>
-            <a:ext cx="4530000" cy="2160479"/>
+            <a:ext cx="4530000" cy="1620359"/>
           </a:xfrm>
           <a:prstGeom prst="rect">
             <a:avLst/>
@@ -5967,8 +5967,8 @@
         </p:nvSpPr>
         <p:spPr>
           <a:xfrm>
-            <a:off x="15246000" y="22678755"/>
-            <a:ext cx="4530000" cy="436349"/>
+            <a:off x="15246000" y="22119208"/>
+            <a:ext cx="4530000" cy="327262"/>
           </a:xfrm>
           <a:prstGeom prst="rect">
             <a:avLst/>
@@ -6071,8 +6071,8 @@
         </p:blipFill>
         <p:spPr>
           <a:xfrm>
-            <a:off x="10500000" y="23455832"/>
-            <a:ext cx="4530000" cy="2691057"/>
+            <a:off x="10500000" y="22702016"/>
+            <a:ext cx="4530000" cy="2018293"/>
           </a:xfrm>
           <a:prstGeom prst="rect">
             <a:avLst/>
@@ -6092,8 +6092,8 @@
         </p:nvSpPr>
         <p:spPr>
           <a:xfrm>
-            <a:off x="10500000" y="26224596"/>
-            <a:ext cx="4530000" cy="436349"/>
+            <a:off x="10500000" y="24778589"/>
+            <a:ext cx="4530000" cy="327262"/>
           </a:xfrm>
           <a:prstGeom prst="rect">
             <a:avLst/>
@@ -6160,8 +6160,8 @@
         </p:blipFill>
         <p:spPr>
           <a:xfrm>
-            <a:off x="15246000" y="23455832"/>
-            <a:ext cx="4530000" cy="1503249"/>
+            <a:off x="15246000" y="22702016"/>
+            <a:ext cx="4530000" cy="1127437"/>
           </a:xfrm>
           <a:prstGeom prst="rect">
             <a:avLst/>
@@ -6181,8 +6181,8 @@
         </p:nvSpPr>
         <p:spPr>
           <a:xfrm>
-            <a:off x="15246000" y="25036789"/>
-            <a:ext cx="4530000" cy="436349"/>
+            <a:off x="15246000" y="23887734"/>
+            <a:ext cx="4530000" cy="327262"/>
           </a:xfrm>
           <a:prstGeom prst="rect">
             <a:avLst/>
@@ -7546,9 +7546,334 @@
           </a:p>
         </p:txBody>
       </p:sp>
+      <p:sp>
+        <p:nvSpPr>
+          <p:cNvPr id="64" name="TextBox 63"/>
+          <p:cNvSpPr txBox="1"/>
+          <p:nvPr/>
+        </p:nvSpPr>
+        <p:spPr>
+          <a:xfrm>
+            <a:off x="20352000" y="28328362"/>
+            <a:ext cx="9276000" cy="8747426"/>
+          </a:xfrm>
+          <a:prstGeom prst="rect">
+            <a:avLst/>
+          </a:prstGeom>
+          <a:noFill/>
+        </p:spPr>
+        <p:txBody>
+          <a:bodyPr wrap="square">
+            <a:spAutoFit/>
+          </a:bodyPr>
+          <a:lstStyle/>
+          <a:p>
+            <a:pPr algn="l">
+              <a:spcAft>
+                <a:spcPts val="600"/>
+              </a:spcAft>
+            </a:pPr>
+            <a:r>
+              <a:rPr sz="1903">
+                <a:solidFill>
+                  <a:srgbClr val="4EB39A"/>
+                </a:solidFill>
+                <a:latin typeface="Calibri"/>
+              </a:rPr>
+              <a:t>■  </a:t>
+            </a:r>
+            <a:r>
+              <a:rPr sz="1903" b="1">
+                <a:solidFill>
+                  <a:srgbClr val="1A1A1A"/>
+                </a:solidFill>
+                <a:latin typeface="Calibri"/>
+              </a:rPr>
+              <a:t>Zero-transfer: </a:t>
+            </a:r>
+            <a:r>
+              <a:rPr sz="1903">
+                <a:solidFill>
+                  <a:srgbClr val="1A1A1A"/>
+                </a:solidFill>
+                <a:latin typeface="Calibri"/>
+              </a:rPr>
+              <a:t>collapses on Task B (M6: 0.82 -&gt; 0.47 Macro F1) but still detects most originals (M1 79.6%, M6 63.8%) - the failure is discrimination, not detection.</a:t>
+            </a:r>
+          </a:p>
+          <a:p>
+            <a:pPr algn="l">
+              <a:spcAft>
+                <a:spcPts val="600"/>
+              </a:spcAft>
+            </a:pPr>
+            <a:r>
+              <a:rPr sz="1903">
+                <a:solidFill>
+                  <a:srgbClr val="4EB39A"/>
+                </a:solidFill>
+                <a:latin typeface="Calibri"/>
+              </a:rPr>
+              <a:t>■  </a:t>
+            </a:r>
+            <a:r>
+              <a:rPr sz="1903" b="1">
+                <a:solidFill>
+                  <a:srgbClr val="1A1A1A"/>
+                </a:solidFill>
+                <a:latin typeface="Calibri"/>
+              </a:rPr>
+              <a:t>Domain adaptation: </a:t>
+            </a:r>
+            <a:r>
+              <a:rPr sz="1903">
+                <a:solidFill>
+                  <a:srgbClr val="1A1A1A"/>
+                </a:solidFill>
+                <a:latin typeface="Calibri"/>
+              </a:rPr>
+              <a:t>combining SIGN Train with Dataset A (not replacing it) closes most of the SIGN gap while Dataset A stays intact - M6 0.82 -&gt; 0.82 exactly, M1 0.74 -&gt; 0.75.</a:t>
+            </a:r>
+          </a:p>
+          <a:p>
+            <a:pPr algn="l">
+              <a:spcAft>
+                <a:spcPts val="600"/>
+              </a:spcAft>
+            </a:pPr>
+            <a:r>
+              <a:rPr sz="1903">
+                <a:solidFill>
+                  <a:srgbClr val="4EB39A"/>
+                </a:solidFill>
+                <a:latin typeface="Calibri"/>
+              </a:rPr>
+              <a:t>■  </a:t>
+            </a:r>
+            <a:r>
+              <a:rPr sz="1903" b="1">
+                <a:solidFill>
+                  <a:srgbClr val="1A1A1A"/>
+                </a:solidFill>
+                <a:latin typeface="Calibri"/>
+              </a:rPr>
+              <a:t>Sharpest finding: </a:t>
+            </a:r>
+            <a:r>
+              <a:rPr sz="1903">
+                <a:solidFill>
+                  <a:srgbClr val="1A1A1A"/>
+                </a:solidFill>
+                <a:latin typeface="Calibri"/>
+              </a:rPr>
+              <a:t>more SIGN data or interpretations improve M6 on both Task A and Task B; the same signal forces M1 to trade Task A for Task B (74.7% -&gt; 55.9% detection as k grows) - a real model-capacity contrast, repeated across 3 independent experiments.</a:t>
+            </a:r>
+          </a:p>
+          <a:p>
+            <a:pPr>
+              <a:spcAft>
+                <a:spcPts val="600"/>
+              </a:spcAft>
+            </a:pPr>
+            <a:r>
+              <a:rPr sz="1903">
+                <a:solidFill>
+                  <a:srgbClr val="4EB39A"/>
+                </a:solidFill>
+                <a:latin typeface="Calibri"/>
+              </a:rPr>
+              <a:t>■  </a:t>
+            </a:r>
+            <a:r>
+              <a:rPr sz="1903" b="1">
+                <a:solidFill>
+                  <a:srgbClr val="1A1A1A"/>
+                </a:solidFill>
+                <a:latin typeface="Calibri"/>
+              </a:rPr>
+              <a:t>Family evaluation: </a:t>
+            </a:r>
+            <a:r>
+              <a:rPr sz="1903">
+                <a:solidFill>
+                  <a:srgbClr val="1A1A1A"/>
+                </a:solidFill>
+                <a:latin typeface="Calibri"/>
+              </a:rPr>
+              <a:t>getting an entire family right (original + all 5 interpretations) is near-unsolved for every method (0-3.8%) -- one interpretation right per family is plausible, all five is not.</a:t>
+            </a:r>
+          </a:p>
+          <a:p>
+            <a:pPr>
+              <a:spcAft>
+                <a:spcPts val="600"/>
+              </a:spcAft>
+            </a:pPr>
+            <a:r>
+              <a:rPr sz="1903">
+                <a:solidFill>
+                  <a:srgbClr val="4EB39A"/>
+                </a:solidFill>
+                <a:latin typeface="Calibri"/>
+              </a:rPr>
+              <a:t>■  </a:t>
+            </a:r>
+            <a:r>
+              <a:rPr sz="1903" b="1">
+                <a:solidFill>
+                  <a:srgbClr val="1A1A1A"/>
+                </a:solidFill>
+                <a:latin typeface="Calibri"/>
+              </a:rPr>
+              <a:t>Cross-phase link: </a:t>
+            </a:r>
+            <a:r>
+              <a:rPr sz="1903">
+                <a:solidFill>
+                  <a:srgbClr val="1A1A1A"/>
+                </a:solidFill>
+                <a:latin typeface="Calibri"/>
+              </a:rPr>
+              <a:t>zero-shot Qwen3-4B detects 93.6% of SIGN originals (Task A) -- far above its own weaker Dataset A score -- pointing to a calibration limitation in prompted classification, not an inability to recognize sarcasm.</a:t>
+            </a:r>
+          </a:p>
+          <a:p>
+            <a:pPr>
+              <a:spcBef>
+                <a:spcPts val="1000"/>
+              </a:spcBef>
+            </a:pPr>
+            <a:r>
+              <a:rPr sz="1903" i="1">
+                <a:solidFill>
+                  <a:srgbClr val="0B2A4A"/>
+                </a:solidFill>
+                <a:latin typeface="Calibri"/>
+              </a:rPr>
+              <a:t>Conclusion: sarcasm detection transfers reasonably out-of-domain; the real gap is contrastive discrimination, closed by combining (not replacing) training data - at a real cost for a capacity-limited model, near-zero cost for a fine-tuned one.</a:t>
+            </a:r>
+          </a:p>
+        </p:txBody>
+      </p:sp>
       <p:pic>
         <p:nvPicPr>
-          <p:cNvPr id="60" name="Picture 59" descr="learning_curve.png"/>
+          <p:cNvPr id="65" name="Picture 64" descr="confusion_matrices_m1_m6.png"/>
+          <p:cNvPicPr>
+            <a:picLocks noChangeAspect="1"/>
+          </p:cNvPicPr>
+          <p:nvPr/>
+        </p:nvPicPr>
+        <p:blipFill>
+          <a:blip r:embed="rId12"/>
+          <a:stretch>
+            <a:fillRect/>
+          </a:stretch>
+        </p:blipFill>
+        <p:spPr>
+          <a:xfrm>
+            <a:off x="12214923" y="25195851"/>
+            <a:ext cx="3313283" cy="1900000"/>
+          </a:xfrm>
+          <a:prstGeom prst="rect">
+            <a:avLst/>
+          </a:prstGeom>
+        </p:spPr>
+      </p:pic>
+      <p:sp>
+        <p:nvSpPr>
+          <p:cNvPr id="66" name="TextBox 65"/>
+          <p:cNvSpPr txBox="1"/>
+          <p:nvPr/>
+        </p:nvSpPr>
+        <p:spPr>
+          <a:xfrm>
+            <a:off x="10500000" y="27115851"/>
+            <a:ext cx="9276000" cy="180000"/>
+          </a:xfrm>
+          <a:prstGeom prst="rect">
+            <a:avLst/>
+          </a:prstGeom>
+          <a:noFill/>
+        </p:spPr>
+        <p:txBody>
+          <a:bodyPr wrap="square">
+            <a:spAutoFit/>
+          </a:bodyPr>
+          <a:lstStyle/>
+          <a:p>
+            <a:r>
+              <a:rPr sz="1480">
+                <a:solidFill>
+                  <a:srgbClr val="1A1A1A"/>
+                </a:solidFill>
+                <a:latin typeface="Calibri"/>
+              </a:rPr>
+              <a:t>Fig. 9 - Confusion matrices on TEST: M1 vs. M6, the two label-trained methods</a:t>
+            </a:r>
+          </a:p>
+        </p:txBody>
+      </p:sp>
+      <p:pic>
+        <p:nvPicPr>
+          <p:cNvPr id="67" name="Picture 66" descr="linguistic_1_length_comparison.png"/>
+          <p:cNvPicPr>
+            <a:picLocks noChangeAspect="1"/>
+          </p:cNvPicPr>
+          <p:nvPr/>
+        </p:nvPicPr>
+        <p:blipFill>
+          <a:blip r:embed="rId13"/>
+          <a:stretch>
+            <a:fillRect/>
+          </a:stretch>
+        </p:blipFill>
+        <p:spPr>
+          <a:xfrm>
+            <a:off x="13747091" y="14089415"/>
+            <a:ext cx="2842572" cy="1700000"/>
+          </a:xfrm>
+          <a:prstGeom prst="rect">
+            <a:avLst/>
+          </a:prstGeom>
+        </p:spPr>
+      </p:pic>
+      <p:sp>
+        <p:nvSpPr>
+          <p:cNvPr id="68" name="TextBox 67"/>
+          <p:cNvSpPr txBox="1"/>
+          <p:nvPr/>
+        </p:nvSpPr>
+        <p:spPr>
+          <a:xfrm>
+            <a:off x="10500000" y="15809415"/>
+            <a:ext cx="9276000" cy="180000"/>
+          </a:xfrm>
+          <a:prstGeom prst="rect">
+            <a:avLst/>
+          </a:prstGeom>
+          <a:noFill/>
+        </p:spPr>
+        <p:txBody>
+          <a:bodyPr wrap="square">
+            <a:spAutoFit/>
+          </a:bodyPr>
+          <a:lstStyle/>
+          <a:p>
+            <a:r>
+              <a:rPr sz="1309">
+                <a:solidFill>
+                  <a:srgbClr val="1A1A1A"/>
+                </a:solidFill>
+                <a:latin typeface="Calibri"/>
+              </a:rPr>
+              <a:t>Fig. 4 - Word count, source vs. interpretation, by model</a:t>
+            </a:r>
+          </a:p>
+        </p:txBody>
+      </p:sp>
+      <p:pic>
+        <p:nvPicPr>
+          <p:cNvPr id="69" name="Picture 68" descr="image.png"/>
           <p:cNvPicPr>
             <a:picLocks noChangeAspect="1"/>
           </p:cNvPicPr>
@@ -7562,8 +7887,8 @@
         </p:blipFill>
         <p:spPr>
           <a:xfrm>
-            <a:off x="10558000" y="28328362"/>
-            <a:ext cx="9160000" cy="4148713"/>
+            <a:off x="13138000" y="28328362"/>
+            <a:ext cx="4277778" cy="1750000"/>
           </a:xfrm>
           <a:prstGeom prst="rect">
             <a:avLst/>
@@ -7572,13 +7897,13 @@
       </p:pic>
       <p:sp>
         <p:nvSpPr>
-          <p:cNvPr id="61" name="TextBox 60"/>
+          <p:cNvPr id="70" name="TextBox 69"/>
           <p:cNvSpPr txBox="1"/>
           <p:nvPr/>
         </p:nvSpPr>
         <p:spPr>
           <a:xfrm>
-            <a:off x="10500000" y="32497075"/>
+            <a:off x="10500000" y="30093362"/>
             <a:ext cx="9276000" cy="180000"/>
           </a:xfrm>
           <a:prstGeom prst="rect">
@@ -7606,7 +7931,7 @@
       </p:sp>
       <p:pic>
         <p:nvPicPr>
-          <p:cNvPr id="62" name="Picture 61" descr="ablation_chart.png"/>
+          <p:cNvPr id="71" name="Picture 70" descr="image.png"/>
           <p:cNvPicPr>
             <a:picLocks noChangeAspect="1"/>
           </p:cNvPicPr>
@@ -7620,8 +7945,8 @@
         </p:blipFill>
         <p:spPr>
           <a:xfrm>
-            <a:off x="10558000" y="32747075"/>
-            <a:ext cx="9160000" cy="4148713"/>
+            <a:off x="13138000" y="30343362"/>
+            <a:ext cx="4476744" cy="1750000"/>
           </a:xfrm>
           <a:prstGeom prst="rect">
             <a:avLst/>
@@ -7630,13 +7955,13 @@
       </p:pic>
       <p:sp>
         <p:nvSpPr>
-          <p:cNvPr id="63" name="TextBox 62"/>
+          <p:cNvPr id="72" name="TextBox 71"/>
           <p:cNvSpPr txBox="1"/>
           <p:nvPr/>
         </p:nvSpPr>
         <p:spPr>
           <a:xfrm>
-            <a:off x="10500000" y="36915788"/>
+            <a:off x="10500000" y="32108362"/>
             <a:ext cx="9276000" cy="180000"/>
           </a:xfrm>
           <a:prstGeom prst="rect">
@@ -7662,16 +7987,40 @@
           </a:p>
         </p:txBody>
       </p:sp>
-      <p:sp>
-        <p:nvSpPr>
-          <p:cNvPr id="64" name="TextBox 63"/>
+      <p:pic>
+        <p:nvPicPr>
+          <p:cNvPr id="73" name="Picture 72" descr="domain_adaptation_chart.png"/>
+          <p:cNvPicPr>
+            <a:picLocks noChangeAspect="1"/>
+          </p:cNvPicPr>
+          <p:nvPr/>
+        </p:nvPicPr>
+        <p:blipFill>
+          <a:blip r:embed="rId14"/>
+          <a:stretch>
+            <a:fillRect/>
+          </a:stretch>
+        </p:blipFill>
+        <p:spPr>
+          <a:xfrm>
+            <a:off x="12899628" y="32358362"/>
+            <a:ext cx="4476744" cy="1750000"/>
+          </a:xfrm>
+          <a:prstGeom prst="rect">
+            <a:avLst/>
+          </a:prstGeom>
+        </p:spPr>
+      </p:pic>
+      <p:sp>
+        <p:nvSpPr>
+          <p:cNvPr id="74" name="TextBox 73"/>
           <p:cNvSpPr txBox="1"/>
           <p:nvPr/>
         </p:nvSpPr>
         <p:spPr>
           <a:xfrm>
-            <a:off x="20352000" y="28328362"/>
-            <a:ext cx="9276000" cy="8747426"/>
+            <a:off x="10500000" y="34123362"/>
+            <a:ext cx="9276000" cy="180000"/>
           </a:xfrm>
           <a:prstGeom prst="rect">
             <a:avLst/>
@@ -7684,189 +8033,72 @@
           </a:bodyPr>
           <a:lstStyle/>
           <a:p>
-            <a:pPr algn="l">
-              <a:spcAft>
-                <a:spcPts val="600"/>
-              </a:spcAft>
-            </a:pPr>
-            <a:r>
-              <a:rPr sz="1903">
-                <a:solidFill>
-                  <a:srgbClr val="4EB39A"/>
-                </a:solidFill>
-                <a:latin typeface="Calibri"/>
-              </a:rPr>
-              <a:t>■  </a:t>
-            </a:r>
-            <a:r>
-              <a:rPr sz="1903" b="1">
-                <a:solidFill>
-                  <a:srgbClr val="1A1A1A"/>
-                </a:solidFill>
-                <a:latin typeface="Calibri"/>
-              </a:rPr>
-              <a:t>Zero-transfer: </a:t>
-            </a:r>
-            <a:r>
-              <a:rPr sz="1903">
-                <a:solidFill>
-                  <a:srgbClr val="1A1A1A"/>
-                </a:solidFill>
-                <a:latin typeface="Calibri"/>
-              </a:rPr>
-              <a:t>collapses on Task B (M6: 0.82 -&gt; 0.47 Macro F1) but still detects most originals (M1 79.6%, M6 63.8%) - the failure is discrimination, not detection.</a:t>
-            </a:r>
-          </a:p>
-          <a:p>
-            <a:pPr algn="l">
-              <a:spcAft>
-                <a:spcPts val="600"/>
-              </a:spcAft>
-            </a:pPr>
-            <a:r>
-              <a:rPr sz="1903">
-                <a:solidFill>
-                  <a:srgbClr val="4EB39A"/>
-                </a:solidFill>
-                <a:latin typeface="Calibri"/>
-              </a:rPr>
-              <a:t>■  </a:t>
-            </a:r>
-            <a:r>
-              <a:rPr sz="1903" b="1">
-                <a:solidFill>
-                  <a:srgbClr val="1A1A1A"/>
-                </a:solidFill>
-                <a:latin typeface="Calibri"/>
-              </a:rPr>
-              <a:t>Domain adaptation: </a:t>
-            </a:r>
-            <a:r>
-              <a:rPr sz="1903">
-                <a:solidFill>
-                  <a:srgbClr val="1A1A1A"/>
-                </a:solidFill>
-                <a:latin typeface="Calibri"/>
-              </a:rPr>
-              <a:t>combining SIGN Train with Dataset A (not replacing it) closes most of the SIGN gap while Dataset A stays intact - M6 0.82 -&gt; 0.82 exactly, M1 0.74 -&gt; 0.75.</a:t>
-            </a:r>
-          </a:p>
-          <a:p>
-            <a:pPr algn="l">
-              <a:spcAft>
-                <a:spcPts val="600"/>
-              </a:spcAft>
-            </a:pPr>
-            <a:r>
-              <a:rPr sz="1903">
-                <a:solidFill>
-                  <a:srgbClr val="4EB39A"/>
-                </a:solidFill>
-                <a:latin typeface="Calibri"/>
-              </a:rPr>
-              <a:t>■  </a:t>
-            </a:r>
-            <a:r>
-              <a:rPr sz="1903" b="1">
-                <a:solidFill>
-                  <a:srgbClr val="1A1A1A"/>
-                </a:solidFill>
-                <a:latin typeface="Calibri"/>
-              </a:rPr>
-              <a:t>Sharpest finding: </a:t>
-            </a:r>
-            <a:r>
-              <a:rPr sz="1903">
-                <a:solidFill>
-                  <a:srgbClr val="1A1A1A"/>
-                </a:solidFill>
-                <a:latin typeface="Calibri"/>
-              </a:rPr>
-              <a:t>more SIGN data or interpretations improve M6 on both Task A and Task B; the same signal forces M1 to trade Task A for Task B (74.7% -&gt; 55.9% detection as k grows) - a real model-capacity contrast, repeated across 3 independent experiments.</a:t>
-            </a:r>
-          </a:p>
-          <a:p>
-            <a:pPr>
-              <a:spcAft>
-                <a:spcPts val="600"/>
-              </a:spcAft>
-            </a:pPr>
-            <a:r>
-              <a:rPr sz="1903">
-                <a:solidFill>
-                  <a:srgbClr val="4EB39A"/>
-                </a:solidFill>
-                <a:latin typeface="Calibri"/>
-              </a:rPr>
-              <a:t>■  </a:t>
-            </a:r>
-            <a:r>
-              <a:rPr sz="1903" b="1">
-                <a:solidFill>
-                  <a:srgbClr val="1A1A1A"/>
-                </a:solidFill>
-                <a:latin typeface="Calibri"/>
-              </a:rPr>
-              <a:t>Family evaluation: </a:t>
-            </a:r>
-            <a:r>
-              <a:rPr sz="1903">
-                <a:solidFill>
-                  <a:srgbClr val="1A1A1A"/>
-                </a:solidFill>
-                <a:latin typeface="Calibri"/>
-              </a:rPr>
-              <a:t>getting an entire family right (original + all 5 interpretations) is near-unsolved for every method (0-3.8%) -- one interpretation right per family is plausible, all five is not.</a:t>
-            </a:r>
-          </a:p>
-          <a:p>
-            <a:pPr>
-              <a:spcAft>
-                <a:spcPts val="600"/>
-              </a:spcAft>
-            </a:pPr>
-            <a:r>
-              <a:rPr sz="1903">
-                <a:solidFill>
-                  <a:srgbClr val="4EB39A"/>
-                </a:solidFill>
-                <a:latin typeface="Calibri"/>
-              </a:rPr>
-              <a:t>■  </a:t>
-            </a:r>
-            <a:r>
-              <a:rPr sz="1903" b="1">
-                <a:solidFill>
-                  <a:srgbClr val="1A1A1A"/>
-                </a:solidFill>
-                <a:latin typeface="Calibri"/>
-              </a:rPr>
-              <a:t>Cross-phase link: </a:t>
-            </a:r>
-            <a:r>
-              <a:rPr sz="1903">
-                <a:solidFill>
-                  <a:srgbClr val="1A1A1A"/>
-                </a:solidFill>
-                <a:latin typeface="Calibri"/>
-              </a:rPr>
-              <a:t>zero-shot Qwen3-4B detects 93.6% of SIGN originals (Task A) -- far above its own weaker Dataset A score -- pointing to a calibration limitation in prompted classification, not an inability to recognize sarcasm.</a:t>
-            </a:r>
-          </a:p>
-          <a:p>
-            <a:pPr>
-              <a:spcBef>
-                <a:spcPts val="1000"/>
-              </a:spcBef>
-            </a:pPr>
-            <a:r>
-              <a:rPr sz="1903" i="1">
-                <a:solidFill>
-                  <a:srgbClr val="0B2A4A"/>
-                </a:solidFill>
-                <a:latin typeface="Calibri"/>
-              </a:rPr>
-              <a:t>Conclusion: sarcasm detection transfers reasonably out-of-domain; the real gap is contrastive discrimination, closed by combining (not replacing) training data - at a real cost for a capacity-limited model, near-zero cost for a fine-tuned one.</a:t>
+            <a:r>
+              <a:rPr sz="1480">
+                <a:solidFill>
+                  <a:srgbClr val="1A1A1A"/>
+                </a:solidFill>
+                <a:latin typeface="Calibri"/>
+              </a:rPr>
+              <a:t>Fig. 11 - Domain adaptation effect on SIGN Test vs. Dataset A TEST (M1 vs. M6)</a:t>
+            </a:r>
+          </a:p>
+        </p:txBody>
+      </p:sp>
+      <p:pic>
+        <p:nvPicPr>
+          <p:cNvPr id="75" name="Picture 74" descr="length_distribution.png"/>
+          <p:cNvPicPr>
+            <a:picLocks noChangeAspect="1"/>
+          </p:cNvPicPr>
+          <p:nvPr/>
+        </p:nvPicPr>
+        <p:blipFill>
+          <a:blip r:embed="rId15"/>
+          <a:stretch>
+            <a:fillRect/>
+          </a:stretch>
+        </p:blipFill>
+        <p:spPr>
+          <a:xfrm>
+            <a:off x="13685872" y="34373362"/>
+            <a:ext cx="2893085" cy="1750000"/>
+          </a:xfrm>
+          <a:prstGeom prst="rect">
+            <a:avLst/>
+          </a:prstGeom>
+        </p:spPr>
+      </p:pic>
+      <p:sp>
+        <p:nvSpPr>
+          <p:cNvPr id="76" name="TextBox 75"/>
+          <p:cNvSpPr txBox="1"/>
+          <p:nvPr/>
+        </p:nvSpPr>
+        <p:spPr>
+          <a:xfrm>
+            <a:off x="10500000" y="36138362"/>
+            <a:ext cx="9276000" cy="180000"/>
+          </a:xfrm>
+          <a:prstGeom prst="rect">
+            <a:avLst/>
+          </a:prstGeom>
+          <a:noFill/>
+        </p:spPr>
+        <p:txBody>
+          <a:bodyPr wrap="square">
+            <a:spAutoFit/>
+          </a:bodyPr>
+          <a:lstStyle/>
+          <a:p>
+            <a:r>
+              <a:rPr sz="1480">
+                <a:solidFill>
+                  <a:srgbClr val="1A1A1A"/>
+                </a:solidFill>
+                <a:latin typeface="Calibri"/>
+              </a:rPr>
+              <a:t>Fig. 12 - Word-length distribution: Dataset A vs. SIGN originals/interpretations</a:t>
             </a:r>
           </a:p>
         </p:txBody>

</xml_diff>